<commit_message>
Updates for PSConf.EU 2026
</commit_message>
<xml_diff>
--- a/PSCONF26_Payette_Designing_PowerShell.pptx
+++ b/PSCONF26_Payette_Designing_PowerShell.pptx
@@ -389,7 +389,7 @@
           <a:p>
             <a:fld id="{69440670-43D7-400A-ABC5-B69E064DBB37}" type="datetimeFigureOut">
               <a:rPr lang="en-GB" smtClean="0"/>
-              <a:t>23/05/2026</a:t>
+              <a:t>30/05/2026</a:t>
             </a:fld>
             <a:endParaRPr lang="en-GB"/>
           </a:p>
@@ -566,7 +566,7 @@
           <a:p>
             <a:fld id="{611B03A4-75C9-4E3D-9183-2102CA9AEC33}" type="datetimeFigureOut">
               <a:rPr lang="en-GB" smtClean="0"/>
-              <a:t>23/05/2026</a:t>
+              <a:t>30/05/2026</a:t>
             </a:fld>
             <a:endParaRPr lang="en-GB"/>
           </a:p>
@@ -6019,18 +6019,20 @@
         </p:nvSpPr>
         <p:spPr/>
         <p:txBody>
-          <a:bodyPr/>
+          <a:bodyPr>
+            <a:normAutofit/>
+          </a:bodyPr>
           <a:lstStyle/>
           <a:p>
             <a:r>
-              <a:rPr lang="fr-FR" dirty="0"/>
+              <a:rPr lang="fr-FR" sz="4800" dirty="0"/>
               <a:t>In the </a:t>
             </a:r>
             <a:r>
-              <a:rPr lang="fr-FR" dirty="0" err="1"/>
+              <a:rPr lang="fr-FR" sz="4800" dirty="0" err="1"/>
               <a:t>Beginning</a:t>
             </a:r>
-            <a:endParaRPr lang="en-GB" dirty="0"/>
+            <a:endParaRPr lang="en-GB" sz="4800" dirty="0"/>
           </a:p>
         </p:txBody>
       </p:sp>
@@ -6050,10 +6052,15 @@
             <p:ph idx="1"/>
           </p:nvPr>
         </p:nvSpPr>
-        <p:spPr/>
+        <p:spPr>
+          <a:xfrm>
+            <a:off x="838200" y="1499347"/>
+            <a:ext cx="10515600" cy="4892770"/>
+          </a:xfrm>
+        </p:spPr>
         <p:txBody>
           <a:bodyPr>
-            <a:normAutofit fontScale="85000" lnSpcReduction="20000"/>
+            <a:normAutofit fontScale="92500" lnSpcReduction="10000"/>
           </a:bodyPr>
           <a:lstStyle/>
           <a:p>
@@ -6063,7 +6070,7 @@
             </a:pPr>
             <a:r>
               <a:rPr lang="en-US" dirty="0"/>
-              <a:t>Initial design: the engine was organized as a set of cooperating services</a:t>
+              <a:t>Initial design: PowerShell was organized as a set of cooperating services, everything would be replaceable</a:t>
             </a:r>
           </a:p>
           <a:p>
@@ -6078,21 +6085,6 @@
             <a:r>
               <a:rPr lang="en-US" dirty="0"/>
               <a:t>But out-of-proc microservices would’ve been cool</a:t>
-            </a:r>
-          </a:p>
-          <a:p>
-            <a:pPr lvl="1"/>
-            <a:r>
-              <a:rPr lang="en-US" dirty="0"/>
-              <a:t>The </a:t>
-            </a:r>
-            <a:r>
-              <a:rPr lang="en-US" dirty="0" err="1"/>
-              <a:t>WindowsCompatibility</a:t>
-            </a:r>
-            <a:r>
-              <a:rPr lang="en-US" dirty="0"/>
-              <a:t> module essentially does this</a:t>
             </a:r>
           </a:p>
           <a:p>
@@ -6259,13 +6251,20 @@
             <p:ph type="title"/>
           </p:nvPr>
         </p:nvSpPr>
-        <p:spPr/>
+        <p:spPr>
+          <a:xfrm>
+            <a:off x="838200" y="173784"/>
+            <a:ext cx="9733280" cy="1325563"/>
+          </a:xfrm>
+        </p:spPr>
         <p:txBody>
-          <a:bodyPr/>
+          <a:bodyPr>
+            <a:normAutofit/>
+          </a:bodyPr>
           <a:lstStyle/>
           <a:p>
             <a:r>
-              <a:rPr lang="en-US" dirty="0"/>
+              <a:rPr lang="en-US" sz="4800" dirty="0"/>
               <a:t>In the Beginning (cont’d)</a:t>
             </a:r>
           </a:p>
@@ -6287,16 +6286,21 @@
             <p:ph idx="1"/>
           </p:nvPr>
         </p:nvSpPr>
-        <p:spPr/>
+        <p:spPr>
+          <a:xfrm>
+            <a:off x="838200" y="1499347"/>
+            <a:ext cx="10515600" cy="4677616"/>
+          </a:xfrm>
+        </p:spPr>
         <p:txBody>
           <a:bodyPr>
-            <a:normAutofit fontScale="85000" lnSpcReduction="10000"/>
+            <a:normAutofit fontScale="92500" lnSpcReduction="20000"/>
           </a:bodyPr>
           <a:lstStyle/>
           <a:p>
             <a:r>
               <a:rPr lang="en-US" dirty="0"/>
-              <a:t>Under the </a:t>
+              <a:t>Under this </a:t>
             </a:r>
             <a:r>
               <a:rPr lang="en-US" dirty="0" err="1"/>
@@ -6304,7 +6308,7 @@
             </a:r>
             <a:r>
               <a:rPr lang="en-US" dirty="0"/>
-              <a:t> model, the user would only need to instantiate the required services through dependency injection</a:t>
+              <a:t> model, the user would only need to instantiate and pass the required services through dependency injection</a:t>
             </a:r>
           </a:p>
           <a:p>
@@ -6317,7 +6321,14 @@
           <a:p>
             <a:r>
               <a:rPr lang="en-US" dirty="0"/>
-              <a:t>Using all these services made it hard to work with (LEGO shell?)</a:t>
+              <a:t>Using all these services made it hard to work with</a:t>
+            </a:r>
+          </a:p>
+          <a:p>
+            <a:pPr lvl="1"/>
+            <a:r>
+              <a:rPr lang="en-US" dirty="0"/>
+              <a:t>LEGO shell?</a:t>
             </a:r>
           </a:p>
           <a:p>
@@ -6406,17 +6417,19 @@
         </p:nvSpPr>
         <p:spPr>
           <a:xfrm>
-            <a:off x="838200" y="175472"/>
-            <a:ext cx="9733280" cy="1325563"/>
+            <a:off x="531159" y="175472"/>
+            <a:ext cx="10040321" cy="1325563"/>
           </a:xfrm>
         </p:spPr>
         <p:txBody>
-          <a:bodyPr/>
+          <a:bodyPr>
+            <a:normAutofit/>
+          </a:bodyPr>
           <a:lstStyle/>
           <a:p>
             <a:r>
-              <a:rPr lang="en-US" dirty="0"/>
-              <a:t>3 days later… (4.5/5)</a:t>
+              <a:rPr lang="en-US" sz="4800" dirty="0"/>
+              <a:t>Sessions and Remoting (Rating 4.5/5)</a:t>
             </a:r>
           </a:p>
         </p:txBody>
@@ -6445,21 +6458,20 @@
         </p:spPr>
         <p:txBody>
           <a:bodyPr>
-            <a:normAutofit fontScale="92500" lnSpcReduction="20000"/>
+            <a:normAutofit fontScale="85000" lnSpcReduction="20000"/>
           </a:bodyPr>
           <a:lstStyle/>
           <a:p>
             <a:r>
               <a:rPr lang="en-US" dirty="0"/>
-              <a:t>And PowerShell 2 introduces remoting. Dun </a:t>
-            </a:r>
-            <a:r>
-              <a:rPr lang="en-US" dirty="0" err="1"/>
-              <a:t>dun</a:t>
-            </a:r>
+              <a:t>A big feature of PowerShell 2 was remoting</a:t>
+            </a:r>
+          </a:p>
+          <a:p>
+            <a:pPr lvl="1"/>
             <a:r>
               <a:rPr lang="en-US" dirty="0"/>
-              <a:t> dah!</a:t>
+              <a:t>Metadata-driven serialization</a:t>
             </a:r>
           </a:p>
           <a:p>
@@ -6476,7 +6488,7 @@
           <a:p>
             <a:r>
               <a:rPr lang="en-US" dirty="0"/>
-              <a:t>BUT when the usability folks tested this they found that users thought “</a:t>
+              <a:t>BUT when the usability folks tested this, they found that users thought “</a:t>
             </a:r>
             <a:r>
               <a:rPr lang="en-US" dirty="0" err="1"/>
@@ -6497,7 +6509,7 @@
             <a:pPr lvl="1"/>
             <a:r>
               <a:rPr lang="en-US" dirty="0"/>
-              <a:t>The ideal fix would be to change </a:t>
+              <a:t>The ideal(?) fix would’ve been to change </a:t>
             </a:r>
             <a:r>
               <a:rPr lang="en-US" dirty="0" err="1"/>
@@ -6519,22 +6531,54 @@
             <a:pPr lvl="1"/>
             <a:r>
               <a:rPr lang="en-US" dirty="0"/>
-              <a:t>As a result of this, a new class Session was added</a:t>
+              <a:t>As a result of this, a new class ‘Session’ was added</a:t>
             </a:r>
           </a:p>
           <a:p>
             <a:pPr lvl="1"/>
             <a:r>
               <a:rPr lang="en-US" dirty="0"/>
-              <a:t>Sessions wrap Runspaces which wrap Engine which wrapped SessionState and the Language </a:t>
-            </a:r>
-            <a:r>
-              <a:rPr lang="en-US" dirty="0" err="1"/>
-              <a:t>rubtime</a:t>
+              <a:t>So</a:t>
+            </a:r>
+            <a:r>
+              <a:rPr lang="en-US" i="1" dirty="0"/>
+              <a:t> Session</a:t>
             </a:r>
             <a:r>
               <a:rPr lang="en-US" dirty="0"/>
-              <a:t>.</a:t>
+              <a:t> wraps </a:t>
+            </a:r>
+            <a:r>
+              <a:rPr lang="en-US" i="1" dirty="0"/>
+              <a:t>Runspace</a:t>
+            </a:r>
+            <a:r>
+              <a:rPr lang="en-US" dirty="0"/>
+              <a:t> which wraps </a:t>
+            </a:r>
+            <a:r>
+              <a:rPr lang="en-US" i="1" dirty="0"/>
+              <a:t>Engine</a:t>
+            </a:r>
+            <a:r>
+              <a:rPr lang="en-US" dirty="0"/>
+              <a:t> which wraps </a:t>
+            </a:r>
+            <a:r>
+              <a:rPr lang="en-US" i="1" dirty="0"/>
+              <a:t>SessionState</a:t>
+            </a:r>
+            <a:r>
+              <a:rPr lang="en-US" dirty="0"/>
+              <a:t> and the </a:t>
+            </a:r>
+            <a:r>
+              <a:rPr lang="en-US" i="1" dirty="0"/>
+              <a:t>Language</a:t>
+            </a:r>
+            <a:r>
+              <a:rPr lang="en-US" dirty="0"/>
+              <a:t> runtime.</a:t>
             </a:r>
           </a:p>
         </p:txBody>
@@ -6587,17 +6631,19 @@
         </p:nvSpPr>
         <p:spPr>
           <a:xfrm>
-            <a:off x="838200" y="287867"/>
+            <a:off x="838200" y="106332"/>
             <a:ext cx="9733280" cy="1325563"/>
           </a:xfrm>
         </p:spPr>
         <p:txBody>
-          <a:bodyPr/>
+          <a:bodyPr>
+            <a:normAutofit/>
+          </a:bodyPr>
           <a:lstStyle/>
           <a:p>
             <a:r>
-              <a:rPr lang="en-US" dirty="0"/>
-              <a:t>Parameter Binding (4/5)</a:t>
+              <a:rPr lang="en-US" sz="4800" dirty="0"/>
+              <a:t>Parameter Binding (Rating 4/5)</a:t>
             </a:r>
           </a:p>
         </p:txBody>
@@ -6620,19 +6666,25 @@
         </p:nvSpPr>
         <p:spPr>
           <a:xfrm>
-            <a:off x="838200" y="1371600"/>
-            <a:ext cx="10515600" cy="5198533"/>
+            <a:off x="838200" y="1237129"/>
+            <a:ext cx="10515600" cy="5439335"/>
           </a:xfrm>
         </p:spPr>
         <p:txBody>
           <a:bodyPr>
-            <a:normAutofit lnSpcReduction="10000"/>
+            <a:normAutofit fontScale="92500" lnSpcReduction="20000"/>
           </a:bodyPr>
           <a:lstStyle/>
           <a:p>
             <a:r>
               <a:rPr lang="en-US" dirty="0"/>
-              <a:t>Does a breadth-first search of all of the parameter sets. </a:t>
+              <a:t>Declarative parameter specification (*) interpreted at runtime</a:t>
+            </a:r>
+          </a:p>
+          <a:p>
+            <a:r>
+              <a:rPr lang="en-US" dirty="0"/>
+              <a:t>The binding algorithm does a parallel search through all of the parameter sets</a:t>
             </a:r>
           </a:p>
           <a:p>
@@ -6679,7 +6731,7 @@
           <a:p>
             <a:r>
               <a:rPr lang="en-US" dirty="0"/>
-              <a:t>Dynamic parameters, ubiquitous parameters all make parameter binding ludicrously complicated and slow.</a:t>
+              <a:t>Dynamic parameters, ubiquitous parameters all make parameter binding very complicated and slow</a:t>
             </a:r>
           </a:p>
         </p:txBody>
@@ -6738,14 +6790,16 @@
         </p:nvSpPr>
         <p:spPr/>
         <p:txBody>
-          <a:bodyPr/>
+          <a:bodyPr>
+            <a:normAutofit/>
+          </a:bodyPr>
           <a:lstStyle/>
           <a:p>
             <a:r>
-              <a:rPr lang="fr-FR" dirty="0"/>
-              <a:t>Pipelining (4/5)</a:t>
-            </a:r>
-            <a:endParaRPr lang="en-GB" dirty="0"/>
+              <a:rPr lang="fr-FR" sz="4800" dirty="0"/>
+              <a:t>Pipelining (Rating 3.5/5)</a:t>
+            </a:r>
+            <a:endParaRPr lang="en-GB" sz="4800" dirty="0"/>
           </a:p>
         </p:txBody>
       </p:sp>
@@ -6790,15 +6844,7 @@
             <a:pPr lvl="1"/>
             <a:r>
               <a:rPr lang="en-GB" dirty="0"/>
-              <a:t>This couldn’t work for PowerShell because of the overhead of process creation and, even </a:t>
-            </a:r>
-            <a:r>
-              <a:rPr lang="en-GB"/>
-              <a:t>worse, object </a:t>
-            </a:r>
-            <a:r>
-              <a:rPr lang="en-GB" dirty="0"/>
-              <a:t>serialization.</a:t>
+              <a:t>This couldn’t work for PowerShell because of the overhead of process creation and, even worse, object de/serialization is expensive</a:t>
             </a:r>
           </a:p>
           <a:p>
@@ -6808,7 +6854,7 @@
             </a:pPr>
             <a:r>
               <a:rPr lang="en-GB" dirty="0"/>
-              <a:t>We then considered using threads to implement concurrency, one thread per command but again, lots of overhead.</a:t>
+              <a:t>We then considered using threads to implement concurrency, one thread per command but again, lots of overhead</a:t>
             </a:r>
           </a:p>
           <a:p>
@@ -6828,7 +6874,7 @@
             </a:pPr>
             <a:r>
               <a:rPr lang="en-GB" dirty="0"/>
-              <a:t>NOTE We made cmdlet pipeline support explicit. You had to design your cmdlet to actively participate in pipeline input.</a:t>
+              <a:t>NOTE: We made cmdlet pipeline support explicit. You had to design your cmdlet to actively participate in pipeline input</a:t>
             </a:r>
           </a:p>
         </p:txBody>
@@ -6955,7 +7001,7 @@
         </p:nvSpPr>
         <p:spPr>
           <a:xfrm>
-            <a:off x="513080" y="365125"/>
+            <a:off x="466015" y="0"/>
             <a:ext cx="9733280" cy="1325563"/>
           </a:xfrm>
         </p:spPr>
@@ -6967,7 +7013,7 @@
           <a:p>
             <a:r>
               <a:rPr lang="en-US" sz="4000" dirty="0"/>
-              <a:t>Streaming, Cardinality and Collections (3/5)</a:t>
+              <a:t>Streaming and Cardinality (Rating 3/5)</a:t>
             </a:r>
           </a:p>
         </p:txBody>
@@ -6990,13 +7036,13 @@
         </p:nvSpPr>
         <p:spPr>
           <a:xfrm>
-            <a:off x="905933" y="1446317"/>
+            <a:off x="838200" y="1056352"/>
             <a:ext cx="10515600" cy="5259283"/>
           </a:xfrm>
         </p:spPr>
         <p:txBody>
           <a:bodyPr>
-            <a:normAutofit fontScale="77500" lnSpcReduction="20000"/>
+            <a:normAutofit fontScale="70000" lnSpcReduction="20000"/>
           </a:bodyPr>
           <a:lstStyle/>
           <a:p>
@@ -7013,7 +7059,7 @@
               <a:t> everything which means it flattens collections of collections by one level. (it’s essentially </a:t>
             </a:r>
             <a:r>
-              <a:rPr lang="en-US" dirty="0" err="1"/>
+              <a:rPr lang="en-US" i="1" dirty="0" err="1"/>
               <a:t>flatmap</a:t>
             </a:r>
             <a:r>
@@ -7050,7 +7096,7 @@
             </a:r>
             <a:r>
               <a:rPr lang="en-US" dirty="0"/>
-              <a:t> as input are messed up. The following turns out to be evil:</a:t>
+              <a:t> as input are messed up. The following turns out to be somewhat evil:</a:t>
             </a:r>
           </a:p>
           <a:p>
@@ -7175,7 +7221,25 @@
               <a:rPr lang="en-US" dirty="0">
                 <a:cs typeface="Cascadia Code" panose="020B0609020000020004" pitchFamily="49" charset="0"/>
               </a:rPr>
+              <a:t>Arrays are annoying:</a:t>
+            </a:r>
+          </a:p>
+          <a:p>
+            <a:pPr lvl="1"/>
+            <a:r>
+              <a:rPr lang="en-US" dirty="0">
+                <a:cs typeface="Cascadia Code" panose="020B0609020000020004" pitchFamily="49" charset="0"/>
+              </a:rPr>
               <a:t>No array literals, leading commas are weird.</a:t>
+            </a:r>
+          </a:p>
+          <a:p>
+            <a:pPr lvl="1"/>
+            <a:r>
+              <a:rPr lang="en-US" dirty="0">
+                <a:cs typeface="Cascadia Code" panose="020B0609020000020004" pitchFamily="49" charset="0"/>
+              </a:rPr>
+              <a:t>Too much copying of contents</a:t>
             </a:r>
           </a:p>
           <a:p>
@@ -7330,12 +7394,12 @@
         <p:spPr/>
         <p:txBody>
           <a:bodyPr>
-            <a:normAutofit fontScale="90000"/>
+            <a:normAutofit/>
           </a:bodyPr>
           <a:lstStyle/>
           <a:p>
             <a:r>
-              <a:rPr lang="en-US" dirty="0"/>
+              <a:rPr lang="en-US" sz="4800" dirty="0"/>
               <a:t>Language Syntax &amp; Quoting (4.8/5)</a:t>
             </a:r>
           </a:p>
@@ -7394,13 +7458,13 @@
             <a:pPr lvl="1"/>
             <a:r>
               <a:rPr lang="en-US" dirty="0"/>
-              <a:t>We had a YACC grammar for a while but PowerShell is not an LALR(1) language.</a:t>
+              <a:t>We had a YACC grammar for a while, but PowerShell is not an LALR(1) language.</a:t>
             </a:r>
           </a:p>
           <a:p>
             <a:r>
               <a:rPr lang="en-US" dirty="0"/>
-              <a:t>Reset very early on to use (a subset of) C# (and also Java/</a:t>
+              <a:t>Design reset very early on to use (a subset of) C# (and also Java/</a:t>
             </a:r>
             <a:r>
               <a:rPr lang="en-US" dirty="0" err="1"/>
@@ -7425,7 +7489,7 @@
           </a:p>
           <a:p>
             <a:r>
-              <a:rPr lang="en-US" dirty="0"/>
+              <a:rPr lang="en-US" i="1" dirty="0"/>
               <a:t>Splatting hashtables instead of backquote. Humph</a:t>
             </a:r>
           </a:p>
@@ -7479,11 +7543,13 @@
         </p:nvSpPr>
         <p:spPr/>
         <p:txBody>
-          <a:bodyPr/>
+          <a:bodyPr>
+            <a:normAutofit/>
+          </a:bodyPr>
           <a:lstStyle/>
           <a:p>
             <a:r>
-              <a:rPr lang="en-US" dirty="0"/>
+              <a:rPr lang="en-US" sz="4800" dirty="0"/>
               <a:t>Variables and Scoping (4/5)</a:t>
             </a:r>
           </a:p>
@@ -7514,13 +7580,13 @@
           <a:p>
             <a:r>
               <a:rPr lang="en-US" dirty="0"/>
-              <a:t>Scoping is about the variables your code can see.</a:t>
+              <a:t>Scoping is about what variables your code can see.</a:t>
             </a:r>
           </a:p>
           <a:p>
             <a:r>
               <a:rPr lang="en-US" dirty="0"/>
-              <a:t>Lexical Scoping</a:t>
+              <a:t>Lexical Scoping (C#, Braid do this)</a:t>
             </a:r>
           </a:p>
           <a:p>
@@ -7531,7 +7597,15 @@
             </a:r>
             <a:r>
               <a:rPr lang="en-US" dirty="0"/>
-              <a:t> depends on where things are defined</a:t>
+              <a:t> depends on </a:t>
+            </a:r>
+            <a:r>
+              <a:rPr lang="en-US" i="1" dirty="0"/>
+              <a:t>where</a:t>
+            </a:r>
+            <a:r>
+              <a:rPr lang="en-US" dirty="0"/>
+              <a:t> things are defined</a:t>
             </a:r>
           </a:p>
           <a:p>
@@ -7548,7 +7622,15 @@
             </a:r>
             <a:r>
               <a:rPr lang="en-US" dirty="0"/>
-              <a:t> depends on when things are defined</a:t>
+              <a:t> depends on </a:t>
+            </a:r>
+            <a:r>
+              <a:rPr lang="en-US" i="1" dirty="0"/>
+              <a:t>when</a:t>
+            </a:r>
+            <a:r>
+              <a:rPr lang="en-US" dirty="0"/>
+              <a:t> things are defined</a:t>
             </a:r>
           </a:p>
           <a:p>
@@ -7572,7 +7654,15 @@
             </a:r>
             <a:r>
               <a:rPr lang="en-US" dirty="0"/>
-              <a:t> depends on how things are defined</a:t>
+              <a:t> depends on </a:t>
+            </a:r>
+            <a:r>
+              <a:rPr lang="en-US" i="1" dirty="0"/>
+              <a:t>how</a:t>
+            </a:r>
+            <a:r>
+              <a:rPr lang="en-US" dirty="0"/>
+              <a:t> things are defined</a:t>
             </a:r>
           </a:p>
         </p:txBody>
@@ -7625,12 +7715,14 @@
         </p:nvSpPr>
         <p:spPr/>
         <p:txBody>
-          <a:bodyPr/>
+          <a:bodyPr>
+            <a:noAutofit/>
+          </a:bodyPr>
           <a:lstStyle/>
           <a:p>
             <a:r>
-              <a:rPr lang="en-US" dirty="0"/>
-              <a:t>Types and Conversions (4.5/5)</a:t>
+              <a:rPr lang="en-US" sz="4800" dirty="0"/>
+              <a:t>Types and Conversions (Rating 4.5/5)</a:t>
             </a:r>
           </a:p>
         </p:txBody>
@@ -7660,14 +7752,32 @@
           <a:p>
             <a:r>
               <a:rPr lang="en-US" dirty="0"/>
-              <a:t>Designed to use a very small set of core types: numbers(!), strings, arrays and hashtables</a:t>
-            </a:r>
-          </a:p>
-          <a:p>
+              <a:t>Designed to use a very small set of core types (literals)</a:t>
+            </a:r>
+          </a:p>
+          <a:p>
+            <a:pPr lvl="1"/>
             <a:r>
               <a:rPr lang="en-US" dirty="0"/>
-              <a:t>Type notation: [int] [int[]] [list[int]]</a:t>
-            </a:r>
+              <a:t> numbers(!), strings, arrays(!) and hashtables</a:t>
+            </a:r>
+          </a:p>
+          <a:p>
+            <a:r>
+              <a:rPr lang="en-US" dirty="0"/>
+              <a:t>Type notation: </a:t>
+            </a:r>
+            <a:r>
+              <a:rPr lang="en-US" sz="2800" dirty="0">
+                <a:latin typeface="Cascadia Code" panose="020B0609020000020004" pitchFamily="49" charset="0"/>
+                <a:cs typeface="Cascadia Code" panose="020B0609020000020004" pitchFamily="49" charset="0"/>
+              </a:rPr>
+              <a:t>[int] [int[]] [list[int]]</a:t>
+            </a:r>
+            <a:endParaRPr lang="en-US" dirty="0">
+              <a:latin typeface="Cascadia Code" panose="020B0609020000020004" pitchFamily="49" charset="0"/>
+              <a:cs typeface="Cascadia Code" panose="020B0609020000020004" pitchFamily="49" charset="0"/>
+            </a:endParaRPr>
           </a:p>
           <a:p>
             <a:pPr lvl="1"/>
@@ -7678,23 +7788,27 @@
           </a:p>
           <a:p>
             <a:r>
+              <a:rPr lang="en-US" i="1" dirty="0"/>
+              <a:t>Safe</a:t>
+            </a:r>
+            <a:r>
               <a:rPr lang="en-US" dirty="0"/>
-              <a:t>Promiscuous conversions always applied everywhere</a:t>
+              <a:t> </a:t>
+            </a:r>
+            <a:r>
+              <a:rPr lang="en-US" i="1" dirty="0"/>
+              <a:t>sane</a:t>
+            </a:r>
+            <a:r>
+              <a:rPr lang="en-US" dirty="0"/>
+              <a:t> conversions always applied everywhere</a:t>
             </a:r>
           </a:p>
           <a:p>
             <a:pPr lvl="1"/>
             <a:r>
               <a:rPr lang="en-US" dirty="0"/>
-              <a:t>No stupid or partial </a:t>
-            </a:r>
-            <a:r>
-              <a:rPr lang="en-US" dirty="0" err="1"/>
-              <a:t>convertions</a:t>
-            </a:r>
-            <a:r>
-              <a:rPr lang="en-US" dirty="0"/>
-              <a:t> to help prevent data loss.</a:t>
+              <a:t>No stupid or partial conversions to help prevent data loss.</a:t>
             </a:r>
           </a:p>
         </p:txBody>
@@ -7745,14 +7859,21 @@
             <p:ph type="title"/>
           </p:nvPr>
         </p:nvSpPr>
-        <p:spPr/>
+        <p:spPr>
+          <a:xfrm>
+            <a:off x="675639" y="60960"/>
+            <a:ext cx="9733280" cy="1053995"/>
+          </a:xfrm>
+        </p:spPr>
         <p:txBody>
-          <a:bodyPr/>
+          <a:bodyPr>
+            <a:noAutofit/>
+          </a:bodyPr>
           <a:lstStyle/>
           <a:p>
             <a:r>
-              <a:rPr lang="en-US" dirty="0"/>
-              <a:t>Errors and Error Handling (3/5)</a:t>
+              <a:rPr lang="en-US" sz="4800" dirty="0"/>
+              <a:t>Errors &amp; Error Handling (Rating 3/5)</a:t>
             </a:r>
           </a:p>
         </p:txBody>
@@ -7775,78 +7896,109 @@
         </p:nvSpPr>
         <p:spPr>
           <a:xfrm>
-            <a:off x="784014" y="1561465"/>
-            <a:ext cx="10515600" cy="4568402"/>
+            <a:off x="784014" y="975359"/>
+            <a:ext cx="10515600" cy="6834293"/>
           </a:xfrm>
         </p:spPr>
         <p:txBody>
           <a:bodyPr>
-            <a:normAutofit fontScale="77500" lnSpcReduction="20000"/>
+            <a:normAutofit/>
           </a:bodyPr>
           <a:lstStyle/>
           <a:p>
             <a:r>
-              <a:rPr lang="en-US" dirty="0"/>
-              <a:t>Our initial design was ludicrously complicated. </a:t>
+              <a:rPr lang="en-US" sz="2800" dirty="0"/>
+              <a:t>Multiple error types + error preferences makes the </a:t>
+            </a:r>
+            <a:r>
+              <a:rPr lang="en-US" sz="2800" dirty="0" err="1"/>
+              <a:t>behaviour</a:t>
+            </a:r>
+            <a:r>
+              <a:rPr lang="en-US" sz="2800" dirty="0"/>
+              <a:t> complicated:</a:t>
             </a:r>
           </a:p>
           <a:p>
             <a:pPr lvl="1"/>
             <a:r>
-              <a:rPr lang="en-US" dirty="0"/>
-              <a:t>I actively suppress that memory.</a:t>
-            </a:r>
-          </a:p>
-          <a:p>
-            <a:r>
-              <a:rPr lang="en-US" dirty="0"/>
-              <a:t>Error types:</a:t>
+              <a:rPr lang="en-US" sz="2400" dirty="0"/>
+              <a:t>Terminating and non-terminating errors, $?, $LASTEXITCODE</a:t>
             </a:r>
           </a:p>
           <a:p>
             <a:pPr lvl="1"/>
             <a:r>
-              <a:rPr lang="en-US" dirty="0"/>
-              <a:t>Terminating and non-terminating errors, $?, $LASTEXITCODE</a:t>
+              <a:rPr lang="en-US" sz="2400" dirty="0"/>
+              <a:t>Not all Windows commands set the exit code properly</a:t>
             </a:r>
           </a:p>
           <a:p>
             <a:pPr lvl="1"/>
             <a:r>
-              <a:rPr lang="en-US" dirty="0"/>
-              <a:t>We had the idea of restarting an operation based on the error objects but as far as I know, this is not used.</a:t>
-            </a:r>
-          </a:p>
-          <a:p>
-            <a:r>
-              <a:rPr lang="en-US" dirty="0"/>
+              <a:rPr lang="en-US" sz="2400" dirty="0"/>
+              <a:t>We had the idea of restarting an operation based on the error objects but as far as I know, this is not used</a:t>
+            </a:r>
+          </a:p>
+          <a:p>
+            <a:r>
+              <a:rPr lang="en-US" sz="2800" dirty="0"/>
               <a:t>Redirection of stderr on Unix-like system</a:t>
             </a:r>
           </a:p>
           <a:p>
             <a:pPr lvl="1"/>
             <a:r>
-              <a:rPr lang="en-US" dirty="0"/>
-              <a:t>Uses stderr as an alternate data stream, doesn’t work with PowerShell</a:t>
-            </a:r>
-          </a:p>
-          <a:p>
-            <a:r>
-              <a:rPr lang="en-US" dirty="0"/>
+              <a:rPr lang="en-US" sz="2400" dirty="0"/>
+              <a:t>Uses </a:t>
+            </a:r>
+            <a:r>
+              <a:rPr lang="en-US" sz="2000" dirty="0">
+                <a:latin typeface="Cascadia Code" panose="020B0609020000020004" pitchFamily="49" charset="0"/>
+                <a:cs typeface="Cascadia Code" panose="020B0609020000020004" pitchFamily="49" charset="0"/>
+              </a:rPr>
+              <a:t>stderr</a:t>
+            </a:r>
+            <a:r>
+              <a:rPr lang="en-US" sz="2400" dirty="0"/>
+              <a:t> as an alternate data stream, doesn’t work with PowerShell</a:t>
+            </a:r>
+          </a:p>
+          <a:p>
+            <a:r>
+              <a:rPr lang="en-US" sz="2800" dirty="0"/>
               <a:t>Handling errors</a:t>
             </a:r>
           </a:p>
           <a:p>
             <a:pPr lvl="1"/>
             <a:r>
-              <a:rPr lang="en-US" dirty="0"/>
-              <a:t>trap vs try/catch/finally, IO Redirection, “partial success”</a:t>
-            </a:r>
-          </a:p>
-          <a:p>
-            <a:r>
-              <a:rPr lang="en-US" dirty="0"/>
-              <a:t>Limitation: can’t make errors in scripts work like errors in compiled cmdlets.</a:t>
+              <a:rPr lang="en-US" sz="2000" dirty="0">
+                <a:latin typeface="Cascadia Code" panose="020B0609020000020004" pitchFamily="49" charset="0"/>
+                <a:cs typeface="Cascadia Code" panose="020B0609020000020004" pitchFamily="49" charset="0"/>
+              </a:rPr>
+              <a:t>trap</a:t>
+            </a:r>
+            <a:r>
+              <a:rPr lang="en-US" sz="2400" dirty="0"/>
+              <a:t> vs </a:t>
+            </a:r>
+            <a:r>
+              <a:rPr lang="en-US" sz="2000" dirty="0">
+                <a:latin typeface="Cascadia Code" panose="020B0609020000020004" pitchFamily="49" charset="0"/>
+                <a:cs typeface="Cascadia Code" panose="020B0609020000020004" pitchFamily="49" charset="0"/>
+              </a:rPr>
+              <a:t>try/catch/finally</a:t>
+            </a:r>
+            <a:r>
+              <a:rPr lang="en-US" sz="2400" dirty="0"/>
+              <a:t>, IO Redirection, “partial success”</a:t>
+            </a:r>
+          </a:p>
+          <a:p>
+            <a:r>
+              <a:rPr lang="en-US" sz="2800" dirty="0"/>
+              <a:t>A limitation: can’t make errors in scripts work like errors in compiled cmdlets</a:t>
             </a:r>
           </a:p>
         </p:txBody>
@@ -8033,11 +8185,13 @@
         </p:nvSpPr>
         <p:spPr/>
         <p:txBody>
-          <a:bodyPr/>
+          <a:bodyPr>
+            <a:normAutofit/>
+          </a:bodyPr>
           <a:lstStyle/>
           <a:p>
             <a:r>
-              <a:rPr lang="en-US" dirty="0"/>
+              <a:rPr lang="en-US" sz="4800" dirty="0"/>
               <a:t>Performance (1/5)</a:t>
             </a:r>
           </a:p>
@@ -8059,10 +8213,15 @@
             <p:ph idx="1"/>
           </p:nvPr>
         </p:nvSpPr>
-        <p:spPr/>
+        <p:spPr>
+          <a:xfrm>
+            <a:off x="838200" y="1580029"/>
+            <a:ext cx="10515600" cy="4596934"/>
+          </a:xfrm>
+        </p:spPr>
         <p:txBody>
           <a:bodyPr>
-            <a:normAutofit lnSpcReduction="10000"/>
+            <a:normAutofit fontScale="92500" lnSpcReduction="10000"/>
           </a:bodyPr>
           <a:lstStyle/>
           <a:p>
@@ -8119,6 +8278,12 @@
             <a:r>
               <a:rPr lang="en-US" dirty="0"/>
               <a:t>Returns a collection of PSObjects resulting in many unnecessary allocations</a:t>
+            </a:r>
+          </a:p>
+          <a:p>
+            <a:r>
+              <a:rPr lang="en-US" dirty="0"/>
+              <a:t>Recommended: use static methods for perf</a:t>
             </a:r>
           </a:p>
         </p:txBody>
@@ -8169,23 +8334,28 @@
             <p:ph type="title"/>
           </p:nvPr>
         </p:nvSpPr>
-        <p:spPr/>
+        <p:spPr>
+          <a:xfrm>
+            <a:off x="838200" y="190314"/>
+            <a:ext cx="9733280" cy="1325563"/>
+          </a:xfrm>
+        </p:spPr>
         <p:txBody>
           <a:bodyPr>
-            <a:normAutofit fontScale="90000"/>
+            <a:normAutofit/>
           </a:bodyPr>
           <a:lstStyle/>
           <a:p>
             <a:r>
-              <a:rPr lang="en-US" dirty="0"/>
+              <a:rPr lang="en-US" sz="4800" dirty="0"/>
               <a:t>A Last Tidbit: The </a:t>
             </a:r>
             <a:r>
-              <a:rPr lang="en-US" dirty="0" err="1"/>
+              <a:rPr lang="en-US" sz="4800" dirty="0" err="1"/>
               <a:t>Minishell</a:t>
             </a:r>
             <a:r>
-              <a:rPr lang="en-US" dirty="0"/>
+              <a:rPr lang="en-US" sz="4800" dirty="0"/>
               <a:t> Debacle</a:t>
             </a:r>
           </a:p>
@@ -8207,10 +8377,15 @@
             <p:ph idx="1"/>
           </p:nvPr>
         </p:nvSpPr>
-        <p:spPr/>
+        <p:spPr>
+          <a:xfrm>
+            <a:off x="838200" y="1391771"/>
+            <a:ext cx="10515600" cy="4785192"/>
+          </a:xfrm>
+        </p:spPr>
         <p:txBody>
           <a:bodyPr>
-            <a:normAutofit fontScale="85000" lnSpcReduction="20000"/>
+            <a:normAutofit fontScale="92500" lnSpcReduction="20000"/>
           </a:bodyPr>
           <a:lstStyle/>
           <a:p>
@@ -8248,7 +8423,7 @@
             <a:pPr lvl="1"/>
             <a:r>
               <a:rPr lang="en-US" dirty="0" err="1"/>
-              <a:t>Powershell</a:t>
+              <a:t>powershell</a:t>
             </a:r>
             <a:r>
               <a:rPr lang="en-US" dirty="0"/>
@@ -8272,10 +8447,10 @@
           <a:p>
             <a:r>
               <a:rPr lang="en-US" dirty="0"/>
-              <a:t>Fortunately cooler heads prevailed and we have </a:t>
-            </a:r>
-            <a:r>
-              <a:rPr lang="en-US" dirty="0" err="1"/>
+              <a:t>Fortunately cooler heads prevailed and we have a </a:t>
+            </a:r>
+            <a:r>
+              <a:rPr lang="en-US" i="1" dirty="0" err="1"/>
               <a:t>SingleShell</a:t>
             </a:r>
             <a:r>
@@ -8333,11 +8508,13 @@
         </p:nvSpPr>
         <p:spPr/>
         <p:txBody>
-          <a:bodyPr/>
+          <a:bodyPr>
+            <a:normAutofit/>
+          </a:bodyPr>
           <a:lstStyle/>
           <a:p>
             <a:r>
-              <a:rPr lang="en-US" dirty="0"/>
+              <a:rPr lang="en-US" sz="4800" dirty="0"/>
               <a:t>Conclusions</a:t>
             </a:r>
           </a:p>
@@ -8366,7 +8543,13 @@
           <a:p>
             <a:r>
               <a:rPr lang="en-US" dirty="0"/>
-              <a:t>There are some rough areas but for the most part I think did pretty well..</a:t>
+              <a:t>Overall rating 3.6/5</a:t>
+            </a:r>
+          </a:p>
+          <a:p>
+            <a:r>
+              <a:rPr lang="en-US" dirty="0"/>
+              <a:t>There are some rough areas but for the most part I think we did ok.</a:t>
             </a:r>
           </a:p>
           <a:p>
@@ -8455,7 +8638,7 @@
           </a:lstStyle>
           <a:p>
             <a:r>
-              <a:rPr lang="en-GB"/>
+              <a:rPr lang="en-GB" sz="4800" dirty="0"/>
               <a:t>Q&amp;A</a:t>
             </a:r>
           </a:p>
@@ -8802,7 +8985,7 @@
           </a:lstStyle>
           <a:p>
             <a:r>
-              <a:rPr lang="en-GB"/>
+              <a:rPr lang="en-GB" sz="4800" dirty="0"/>
               <a:t>GIVE ME FEEDBACK</a:t>
             </a:r>
           </a:p>
@@ -9434,7 +9617,7 @@
                 </a:solidFill>
                 <a:latin typeface="+mn-lt"/>
               </a:rPr>
-              <a:t>Leveraging Braid from PowerShell</a:t>
+              <a:t>Designing PowerShell</a:t>
             </a:r>
             <a:endParaRPr lang="en-DE" sz="6000" b="1" dirty="0">
               <a:solidFill>
@@ -9878,7 +10061,7 @@
             </a:pPr>
             <a:r>
               <a:rPr lang="en-US" dirty="0"/>
-              <a:t>Creator of PowerShell DSC</a:t>
+              <a:t>Creator of the original PowerShell DSC</a:t>
             </a:r>
           </a:p>
           <a:p>
@@ -9898,7 +10081,15 @@
             </a:pPr>
             <a:r>
               <a:rPr lang="en-US" dirty="0"/>
-              <a:t>Very interested (ok obsessed) with interactive programming languages</a:t>
+              <a:t>Very </a:t>
+            </a:r>
+            <a:r>
+              <a:rPr lang="en-US"/>
+              <a:t>interested in </a:t>
+            </a:r>
+            <a:r>
+              <a:rPr lang="en-US" dirty="0"/>
+              <a:t>interactive programming languages</a:t>
             </a:r>
           </a:p>
         </p:txBody>
@@ -10047,7 +10238,11 @@
           <a:p>
             <a:pPr lvl="1"/>
             <a:r>
-              <a:rPr lang="en-US" dirty="0"/>
+              <a:rPr lang="en-US" dirty="0">
+                <a:solidFill>
+                  <a:schemeClr val="accent1"/>
+                </a:solidFill>
+              </a:rPr>
               <a:t>Some background on PowerShell</a:t>
             </a:r>
           </a:p>
@@ -10060,15 +10255,23 @@
           <a:p>
             <a:pPr lvl="1"/>
             <a:r>
-              <a:rPr lang="en-US" dirty="0"/>
+              <a:rPr lang="en-US" dirty="0">
+                <a:solidFill>
+                  <a:schemeClr val="accent1"/>
+                </a:solidFill>
+              </a:rPr>
               <a:t>Mostly covering stuff I worked directly on</a:t>
             </a:r>
           </a:p>
           <a:p>
             <a:pPr lvl="1"/>
             <a:r>
-              <a:rPr lang="en-US" dirty="0"/>
-              <a:t>Rating the success of each scenario on a scale of 1-5.</a:t>
+              <a:rPr lang="en-US" dirty="0">
+                <a:solidFill>
+                  <a:schemeClr val="accent1"/>
+                </a:solidFill>
+              </a:rPr>
+              <a:t>Rating the success of each aspect on a scale of 1-5.</a:t>
             </a:r>
           </a:p>
           <a:p>
@@ -10112,11 +10315,15 @@
           </a:xfrm>
         </p:spPr>
         <p:txBody>
-          <a:bodyPr/>
+          <a:bodyPr>
+            <a:normAutofit/>
+          </a:bodyPr>
           <a:lstStyle/>
           <a:p>
             <a:r>
-              <a:rPr lang="en-US" dirty="0"/>
+              <a:rPr lang="en-US" sz="4800" dirty="0">
+                <a:latin typeface="+mn-lt"/>
+              </a:rPr>
               <a:t>Agenda</a:t>
             </a:r>
           </a:p>
@@ -10168,14 +10375,21 @@
             <p:ph type="title"/>
           </p:nvPr>
         </p:nvSpPr>
-        <p:spPr/>
+        <p:spPr>
+          <a:xfrm>
+            <a:off x="838199" y="0"/>
+            <a:ext cx="9733280" cy="1325563"/>
+          </a:xfrm>
+        </p:spPr>
         <p:txBody>
-          <a:bodyPr/>
+          <a:bodyPr>
+            <a:normAutofit/>
+          </a:bodyPr>
           <a:lstStyle/>
           <a:p>
             <a:r>
-              <a:rPr lang="en-US" dirty="0"/>
-              <a:t>High-level Design Goals</a:t>
+              <a:rPr lang="en-US" sz="4800" dirty="0"/>
+              <a:t>High-level PowerShell Design Goals</a:t>
             </a:r>
           </a:p>
         </p:txBody>
@@ -10198,75 +10412,75 @@
         </p:nvSpPr>
         <p:spPr>
           <a:xfrm>
-            <a:off x="838199" y="1605280"/>
-            <a:ext cx="10532533" cy="5012267"/>
+            <a:off x="438572" y="1157287"/>
+            <a:ext cx="10532533" cy="5474547"/>
           </a:xfrm>
         </p:spPr>
         <p:txBody>
           <a:bodyPr>
-            <a:normAutofit fontScale="32500" lnSpcReduction="20000"/>
+            <a:normAutofit/>
           </a:bodyPr>
           <a:lstStyle/>
           <a:p>
             <a:r>
-              <a:rPr lang="en-US" sz="8600" dirty="0"/>
+              <a:rPr lang="en-US" sz="2400" dirty="0"/>
               <a:t>Users are most important than conserving resources. This includes performance. </a:t>
             </a:r>
           </a:p>
           <a:p>
             <a:pPr lvl="1"/>
             <a:r>
-              <a:rPr lang="en-US" sz="8200" dirty="0"/>
+              <a:rPr lang="en-US" sz="2400" dirty="0"/>
               <a:t>When scripting, common scenarios should be super easy, less common scenarios should be possible.</a:t>
             </a:r>
           </a:p>
           <a:p>
             <a:pPr lvl="1"/>
             <a:r>
-              <a:rPr lang="en-US" sz="8200" dirty="0"/>
-              <a:t>Simplified exposing functionality on the command line.</a:t>
-            </a:r>
-          </a:p>
-          <a:p>
-            <a:r>
-              <a:rPr lang="en-US" sz="8600" dirty="0"/>
+              <a:rPr lang="en-US" sz="2400" dirty="0"/>
+              <a:t>Simplify exposing OS functionality on the command line through cmdlets.</a:t>
+            </a:r>
+          </a:p>
+          <a:p>
+            <a:pPr lvl="1"/>
+            <a:r>
+              <a:rPr lang="en-US" sz="2400" dirty="0"/>
+              <a:t>Radical support for copy and paste</a:t>
+            </a:r>
+          </a:p>
+          <a:p>
+            <a:r>
+              <a:rPr lang="en-US" sz="2400" dirty="0"/>
               <a:t>Deep simplicity and deep consistency are king (at least for the </a:t>
             </a:r>
             <a:r>
-              <a:rPr lang="en-US" sz="8600" dirty="0" err="1"/>
+              <a:rPr lang="en-US" sz="2400" dirty="0" err="1"/>
               <a:t>ITPro</a:t>
             </a:r>
             <a:r>
-              <a:rPr lang="en-US" sz="8600" dirty="0"/>
+              <a:rPr lang="en-US" sz="2400" dirty="0"/>
               <a:t> user)</a:t>
             </a:r>
           </a:p>
           <a:p>
             <a:pPr lvl="1"/>
             <a:r>
-              <a:rPr lang="en-US" sz="8300" dirty="0"/>
+              <a:rPr lang="en-US" sz="2400" dirty="0"/>
               <a:t>But beware of the “</a:t>
             </a:r>
             <a:r>
-              <a:rPr lang="en-US" sz="8300" i="1" dirty="0"/>
-              <a:t>Foolish Consistency</a:t>
-            </a:r>
-            <a:r>
-              <a:rPr lang="en-US" sz="8300" dirty="0"/>
-              <a:t>”</a:t>
-            </a:r>
-          </a:p>
-          <a:p>
-            <a:pPr lvl="1"/>
-            <a:r>
-              <a:rPr lang="en-US" sz="8300" dirty="0"/>
-              <a:t>It is possible to over do consistency/simplicity – works in the general case, fails in edge scenarios. Examples:</a:t>
+              <a:rPr lang="en-US" sz="2400" i="1" dirty="0"/>
+              <a:t>foolish consistency</a:t>
+            </a:r>
+            <a:r>
+              <a:rPr lang="en-US" sz="2400" dirty="0"/>
+              <a:t>”. It is possible to over do consistency/simplicity – works in the general case, fails in edge scenarios. Examples:</a:t>
             </a:r>
           </a:p>
           <a:p>
             <a:pPr lvl="2"/>
             <a:r>
-              <a:rPr lang="en-US" sz="6200" dirty="0" err="1">
+              <a:rPr lang="en-US" sz="1800" dirty="0" err="1">
                 <a:solidFill>
                   <a:schemeClr val="accent1"/>
                 </a:solidFill>
@@ -10276,28 +10490,55 @@
               <a:t>ScriptBlock.InvokeReturnAsIs</a:t>
             </a:r>
             <a:r>
-              <a:rPr lang="en-US" sz="6200" dirty="0">
+              <a:rPr lang="en-US" sz="1800" dirty="0">
                 <a:solidFill>
                   <a:schemeClr val="accent1"/>
                 </a:solidFill>
                 <a:latin typeface="Cascadia Code" panose="020B0609020000020004" pitchFamily="49" charset="0"/>
                 <a:cs typeface="Cascadia Code" panose="020B0609020000020004" pitchFamily="49" charset="0"/>
               </a:rPr>
-              <a:t>() </a:t>
-            </a:r>
-            <a:r>
-              <a:rPr lang="en-US" sz="8300" dirty="0">
+              <a:t>() # </a:t>
+            </a:r>
+            <a:r>
+              <a:rPr lang="en-US" sz="1800" dirty="0" err="1">
                 <a:solidFill>
                   <a:schemeClr val="accent1"/>
                 </a:solidFill>
+                <a:latin typeface="Cascadia Code" panose="020B0609020000020004" pitchFamily="49" charset="0"/>
+                <a:cs typeface="Cascadia Code" panose="020B0609020000020004" pitchFamily="49" charset="0"/>
               </a:rPr>
-              <a:t>(sigh)</a:t>
-            </a:r>
+              <a:t>spec’ed</a:t>
+            </a:r>
+            <a:r>
+              <a:rPr lang="en-US" sz="1800" dirty="0">
+                <a:solidFill>
+                  <a:schemeClr val="accent1"/>
+                </a:solidFill>
+                <a:latin typeface="Cascadia Code" panose="020B0609020000020004" pitchFamily="49" charset="0"/>
+                <a:cs typeface="Cascadia Code" panose="020B0609020000020004" pitchFamily="49" charset="0"/>
+              </a:rPr>
+              <a:t> as object, returns </a:t>
+            </a:r>
+            <a:r>
+              <a:rPr lang="en-US" sz="1800" dirty="0" err="1">
+                <a:solidFill>
+                  <a:schemeClr val="accent1"/>
+                </a:solidFill>
+                <a:latin typeface="Cascadia Code" panose="020B0609020000020004" pitchFamily="49" charset="0"/>
+                <a:cs typeface="Cascadia Code" panose="020B0609020000020004" pitchFamily="49" charset="0"/>
+              </a:rPr>
+              <a:t>PSObject</a:t>
+            </a:r>
+            <a:endParaRPr lang="en-US" sz="2000" dirty="0">
+              <a:solidFill>
+                <a:schemeClr val="accent1"/>
+              </a:solidFill>
+            </a:endParaRPr>
           </a:p>
           <a:p>
             <a:pPr lvl="2"/>
             <a:r>
-              <a:rPr lang="en-US" sz="8300" dirty="0">
+              <a:rPr lang="en-US" sz="2400" dirty="0">
                 <a:solidFill>
                   <a:schemeClr val="accent1"/>
                 </a:solidFill>
@@ -10307,15 +10548,15 @@
           </a:p>
           <a:p>
             <a:r>
-              <a:rPr lang="en-US" sz="8600" dirty="0"/>
-              <a:t>The sacred vow – learn once, use forever.</a:t>
+              <a:rPr lang="en-US" sz="2400" dirty="0"/>
+              <a:t>The sacred vow – “learn once, use forever”.</a:t>
             </a:r>
           </a:p>
           <a:p>
             <a:pPr lvl="1"/>
             <a:r>
-              <a:rPr lang="en-US" sz="8300" dirty="0"/>
-              <a:t>Backwards compatibility </a:t>
+              <a:rPr lang="en-US" sz="2400" dirty="0"/>
+              <a:t>Backwards compatibility is super important. </a:t>
             </a:r>
           </a:p>
         </p:txBody>
@@ -12030,26 +12271,6 @@
 </file>
 
 <file path=customXml/item1.xml><?xml version="1.0" encoding="utf-8"?>
-<?mso-contentType ?>
-<FormTemplates xmlns="http://schemas.microsoft.com/sharepoint/v3/contenttype/forms">
-  <Display>DocumentLibraryForm</Display>
-  <Edit>DocumentLibraryForm</Edit>
-  <New>DocumentLibraryForm</New>
-</FormTemplates>
-</file>
-
-<file path=customXml/item2.xml><?xml version="1.0" encoding="utf-8"?>
-<p:properties xmlns:p="http://schemas.microsoft.com/office/2006/metadata/properties" xmlns:xsi="http://www.w3.org/2001/XMLSchema-instance" xmlns:pc="http://schemas.microsoft.com/office/infopath/2007/PartnerControls">
-  <documentManagement>
-    <lcf76f155ced4ddcb4097134ff3c332f xmlns="abdc9a1f-962e-4235-838d-61f9c438f4db">
-      <Terms xmlns="http://schemas.microsoft.com/office/infopath/2007/PartnerControls"/>
-    </lcf76f155ced4ddcb4097134ff3c332f>
-    <TaxCatchAll xmlns="de47e97d-64fd-4aef-b10e-fd7d6cfcfcf4" xsi:nil="true"/>
-  </documentManagement>
-</p:properties>
-</file>
-
-<file path=customXml/item3.xml><?xml version="1.0" encoding="utf-8"?>
 <ct:contentTypeSchema xmlns:ct="http://schemas.microsoft.com/office/2006/metadata/contentType" xmlns:ma="http://schemas.microsoft.com/office/2006/metadata/properties/metaAttributes" ct:_="" ma:_="" ma:contentTypeName="Document" ma:contentTypeID="0x010100333502FDC476714EB47BD1BE2BFD7B3D" ma:contentTypeVersion="13" ma:contentTypeDescription="Create a new document." ma:contentTypeScope="" ma:versionID="0d4fb5ca5076182280cb93c7d6bdff79">
   <xsd:schema xmlns:xsd="http://www.w3.org/2001/XMLSchema" xmlns:xs="http://www.w3.org/2001/XMLSchema" xmlns:p="http://schemas.microsoft.com/office/2006/metadata/properties" xmlns:ns2="abdc9a1f-962e-4235-838d-61f9c438f4db" xmlns:ns3="de47e97d-64fd-4aef-b10e-fd7d6cfcfcf4" targetNamespace="http://schemas.microsoft.com/office/2006/metadata/properties" ma:root="true" ma:fieldsID="da14a0effa8c0f0120811d0692d695e7" ns2:_="" ns3:_="">
     <xsd:import namespace="abdc9a1f-962e-4235-838d-61f9c438f4db"/>
@@ -12256,30 +12477,27 @@
 </ct:contentTypeSchema>
 </file>
 
-<file path=customXml/itemProps1.xml><?xml version="1.0" encoding="utf-8"?>
-<ds:datastoreItem xmlns:ds="http://schemas.openxmlformats.org/officeDocument/2006/customXml" ds:itemID="{57D9B22B-F436-4FE5-B6C0-65AB2260F593}">
-  <ds:schemaRefs>
-    <ds:schemaRef ds:uri="http://schemas.microsoft.com/sharepoint/v3/contenttype/forms"/>
-  </ds:schemaRefs>
-</ds:datastoreItem>
+<file path=customXml/item2.xml><?xml version="1.0" encoding="utf-8"?>
+<?mso-contentType ?>
+<FormTemplates xmlns="http://schemas.microsoft.com/sharepoint/v3/contenttype/forms">
+  <Display>DocumentLibraryForm</Display>
+  <Edit>DocumentLibraryForm</Edit>
+  <New>DocumentLibraryForm</New>
+</FormTemplates>
 </file>
 
-<file path=customXml/itemProps2.xml><?xml version="1.0" encoding="utf-8"?>
-<ds:datastoreItem xmlns:ds="http://schemas.openxmlformats.org/officeDocument/2006/customXml" ds:itemID="{AA9C06E3-346E-408E-B352-32E922A070CE}">
-  <ds:schemaRefs>
-    <ds:schemaRef ds:uri="2347cc20-e10c-452d-848a-c18e83138525"/>
-    <ds:schemaRef ds:uri="58c243a5-121d-4837-b81c-114e1b569ece"/>
-    <ds:schemaRef ds:uri="77f18391-c91f-4725-9130-63caf76c1806"/>
-    <ds:schemaRef ds:uri="85c0ce47-fe9c-4809-bf88-519c39a738e6"/>
-    <ds:schemaRef ds:uri="abdc9a1f-962e-4235-838d-61f9c438f4db"/>
-    <ds:schemaRef ds:uri="de47e97d-64fd-4aef-b10e-fd7d6cfcfcf4"/>
-    <ds:schemaRef ds:uri="http://schemas.microsoft.com/office/2006/metadata/properties"/>
-    <ds:schemaRef ds:uri="http://schemas.microsoft.com/office/infopath/2007/PartnerControls"/>
-  </ds:schemaRefs>
-</ds:datastoreItem>
+<file path=customXml/item3.xml><?xml version="1.0" encoding="utf-8"?>
+<p:properties xmlns:p="http://schemas.microsoft.com/office/2006/metadata/properties" xmlns:xsi="http://www.w3.org/2001/XMLSchema-instance" xmlns:pc="http://schemas.microsoft.com/office/infopath/2007/PartnerControls">
+  <documentManagement>
+    <lcf76f155ced4ddcb4097134ff3c332f xmlns="abdc9a1f-962e-4235-838d-61f9c438f4db">
+      <Terms xmlns="http://schemas.microsoft.com/office/infopath/2007/PartnerControls"/>
+    </lcf76f155ced4ddcb4097134ff3c332f>
+    <TaxCatchAll xmlns="de47e97d-64fd-4aef-b10e-fd7d6cfcfcf4" xsi:nil="true"/>
+  </documentManagement>
+</p:properties>
 </file>
 
-<file path=customXml/itemProps3.xml><?xml version="1.0" encoding="utf-8"?>
+<file path=customXml/itemProps1.xml><?xml version="1.0" encoding="utf-8"?>
 <ds:datastoreItem xmlns:ds="http://schemas.openxmlformats.org/officeDocument/2006/customXml" ds:itemID="{2C38D965-436F-4DCC-97AA-50BEF4F7BE29}">
   <ds:schemaRefs>
     <ds:schemaRef ds:uri="abdc9a1f-962e-4235-838d-61f9c438f4db"/>
@@ -12296,4 +12514,27 @@
     <ds:schemaRef ds:uri="http://www.w3.org/2001/XMLSchema"/>
   </ds:schemaRefs>
 </ds:datastoreItem>
+</file>
+
+<file path=customXml/itemProps2.xml><?xml version="1.0" encoding="utf-8"?>
+<ds:datastoreItem xmlns:ds="http://schemas.openxmlformats.org/officeDocument/2006/customXml" ds:itemID="{57D9B22B-F436-4FE5-B6C0-65AB2260F593}">
+  <ds:schemaRefs>
+    <ds:schemaRef ds:uri="http://schemas.microsoft.com/sharepoint/v3/contenttype/forms"/>
+  </ds:schemaRefs>
+</ds:datastoreItem>
+</file>
+
+<file path=customXml/itemProps3.xml><?xml version="1.0" encoding="utf-8"?>
+<ds:datastoreItem xmlns:ds="http://schemas.openxmlformats.org/officeDocument/2006/customXml" ds:itemID="{AA9C06E3-346E-408E-B352-32E922A070CE}">
+  <ds:schemaRefs>
+    <ds:schemaRef ds:uri="2347cc20-e10c-452d-848a-c18e83138525"/>
+    <ds:schemaRef ds:uri="58c243a5-121d-4837-b81c-114e1b569ece"/>
+    <ds:schemaRef ds:uri="77f18391-c91f-4725-9130-63caf76c1806"/>
+    <ds:schemaRef ds:uri="85c0ce47-fe9c-4809-bf88-519c39a738e6"/>
+    <ds:schemaRef ds:uri="abdc9a1f-962e-4235-838d-61f9c438f4db"/>
+    <ds:schemaRef ds:uri="de47e97d-64fd-4aef-b10e-fd7d6cfcfcf4"/>
+    <ds:schemaRef ds:uri="http://schemas.microsoft.com/office/2006/metadata/properties"/>
+    <ds:schemaRef ds:uri="http://schemas.microsoft.com/office/infopath/2007/PartnerControls"/>
+  </ds:schemaRefs>
+</ds:datastoreItem>
 </file>
</xml_diff>

<commit_message>
More updates for PSConf2026
</commit_message>
<xml_diff>
--- a/PSCONF26_Payette_Designing_PowerShell.pptx
+++ b/PSCONF26_Payette_Designing_PowerShell.pptx
@@ -8,10 +8,10 @@
     <p:sldMasterId id="2147483684" r:id="rId7"/>
   </p:sldMasterIdLst>
   <p:notesMasterIdLst>
-    <p:notesMasterId r:id="rId32"/>
+    <p:notesMasterId r:id="rId33"/>
   </p:notesMasterIdLst>
   <p:handoutMasterIdLst>
-    <p:handoutMasterId r:id="rId33"/>
+    <p:handoutMasterId r:id="rId34"/>
   </p:handoutMasterIdLst>
   <p:sldIdLst>
     <p:sldId id="272" r:id="rId8"/>
@@ -19,7 +19,7 @@
     <p:sldId id="269" r:id="rId10"/>
     <p:sldId id="270" r:id="rId11"/>
     <p:sldId id="273" r:id="rId12"/>
-    <p:sldId id="261" r:id="rId13"/>
+    <p:sldId id="291" r:id="rId13"/>
     <p:sldId id="267" r:id="rId14"/>
     <p:sldId id="289" r:id="rId15"/>
     <p:sldId id="286" r:id="rId16"/>
@@ -34,10 +34,11 @@
     <p:sldId id="282" r:id="rId25"/>
     <p:sldId id="281" r:id="rId26"/>
     <p:sldId id="285" r:id="rId27"/>
-    <p:sldId id="277" r:id="rId28"/>
-    <p:sldId id="283" r:id="rId29"/>
-    <p:sldId id="265" r:id="rId30"/>
-    <p:sldId id="274" r:id="rId31"/>
+    <p:sldId id="290" r:id="rId28"/>
+    <p:sldId id="277" r:id="rId29"/>
+    <p:sldId id="283" r:id="rId30"/>
+    <p:sldId id="265" r:id="rId31"/>
+    <p:sldId id="274" r:id="rId32"/>
   </p:sldIdLst>
   <p:sldSz cx="12192000" cy="6858000"/>
   <p:notesSz cx="6858000" cy="9144000"/>
@@ -150,7 +151,7 @@
         <p14:section name="The session" id="{9BCE8471-468A-4538-82B3-E4E62B0A593E}">
           <p14:sldIdLst>
             <p14:sldId id="273"/>
-            <p14:sldId id="261"/>
+            <p14:sldId id="291"/>
             <p14:sldId id="267"/>
             <p14:sldId id="289"/>
             <p14:sldId id="286"/>
@@ -165,6 +166,7 @@
             <p14:sldId id="282"/>
             <p14:sldId id="281"/>
             <p14:sldId id="285"/>
+            <p14:sldId id="290"/>
             <p14:sldId id="277"/>
             <p14:sldId id="283"/>
             <p14:sldId id="265"/>
@@ -389,7 +391,7 @@
           <a:p>
             <a:fld id="{69440670-43D7-400A-ABC5-B69E064DBB37}" type="datetimeFigureOut">
               <a:rPr lang="en-GB" smtClean="0"/>
-              <a:t>30/05/2026</a:t>
+              <a:t>01/06/2026</a:t>
             </a:fld>
             <a:endParaRPr lang="en-GB"/>
           </a:p>
@@ -566,7 +568,7 @@
           <a:p>
             <a:fld id="{611B03A4-75C9-4E3D-9183-2102CA9AEC33}" type="datetimeFigureOut">
               <a:rPr lang="en-GB" smtClean="0"/>
-              <a:t>30/05/2026</a:t>
+              <a:t>31/05/2026</a:t>
             </a:fld>
             <a:endParaRPr lang="en-GB"/>
           </a:p>
@@ -1175,90 +1177,6 @@
   <p:cSld>
     <p:spTree>
       <p:nvGrpSpPr>
-        <p:cNvPr id="1" name=""/>
-        <p:cNvGrpSpPr/>
-        <p:nvPr/>
-      </p:nvGrpSpPr>
-      <p:grpSpPr>
-        <a:xfrm>
-          <a:off x="0" y="0"/>
-          <a:ext cx="0" cy="0"/>
-          <a:chOff x="0" y="0"/>
-          <a:chExt cx="0" cy="0"/>
-        </a:xfrm>
-      </p:grpSpPr>
-      <p:sp>
-        <p:nvSpPr>
-          <p:cNvPr id="2" name="Espace réservé de l'image des diapositives 1"/>
-          <p:cNvSpPr>
-            <a:spLocks noGrp="1" noRot="1" noChangeAspect="1"/>
-          </p:cNvSpPr>
-          <p:nvPr>
-            <p:ph type="sldImg"/>
-          </p:nvPr>
-        </p:nvSpPr>
-        <p:spPr/>
-      </p:sp>
-      <p:sp>
-        <p:nvSpPr>
-          <p:cNvPr id="3" name="Espace réservé des notes 2"/>
-          <p:cNvSpPr>
-            <a:spLocks noGrp="1"/>
-          </p:cNvSpPr>
-          <p:nvPr>
-            <p:ph type="body" idx="1"/>
-          </p:nvPr>
-        </p:nvSpPr>
-        <p:spPr/>
-        <p:txBody>
-          <a:bodyPr/>
-          <a:lstStyle/>
-          <a:p>
-            <a:endParaRPr lang="en-GB"/>
-          </a:p>
-        </p:txBody>
-      </p:sp>
-      <p:sp>
-        <p:nvSpPr>
-          <p:cNvPr id="4" name="Espace réservé du numéro de diapositive 3"/>
-          <p:cNvSpPr>
-            <a:spLocks noGrp="1"/>
-          </p:cNvSpPr>
-          <p:nvPr>
-            <p:ph type="sldNum" sz="quarter" idx="5"/>
-          </p:nvPr>
-        </p:nvSpPr>
-        <p:spPr/>
-        <p:txBody>
-          <a:bodyPr/>
-          <a:lstStyle/>
-          <a:p>
-            <a:fld id="{A7839206-A81D-4F76-8486-302187992F73}" type="slidenum">
-              <a:rPr lang="en-GB" smtClean="0"/>
-              <a:t>6</a:t>
-            </a:fld>
-            <a:endParaRPr lang="en-GB"/>
-          </a:p>
-        </p:txBody>
-      </p:sp>
-    </p:spTree>
-    <p:extLst>
-      <p:ext uri="{BB962C8B-B14F-4D97-AF65-F5344CB8AC3E}">
-        <p14:creationId xmlns:p14="http://schemas.microsoft.com/office/powerpoint/2010/main" val="529600659"/>
-      </p:ext>
-    </p:extLst>
-  </p:cSld>
-  <p:clrMapOvr>
-    <a:masterClrMapping/>
-  </p:clrMapOvr>
-</p:notes>
-</file>
-
-<file path=ppt/notesSlides/notesSlide6.xml><?xml version="1.0" encoding="utf-8"?>
-<p:notes xmlns:a="http://schemas.openxmlformats.org/drawingml/2006/main" xmlns:r="http://schemas.openxmlformats.org/officeDocument/2006/relationships" xmlns:p="http://schemas.openxmlformats.org/presentationml/2006/main">
-  <p:cSld>
-    <p:spTree>
-      <p:nvGrpSpPr>
         <p:cNvPr id="1" name="">
           <a:extLst>
             <a:ext uri="{FF2B5EF4-FFF2-40B4-BE49-F238E27FC236}">
@@ -1362,7 +1280,7 @@
 </p:notes>
 </file>
 
-<file path=ppt/notesSlides/notesSlide7.xml><?xml version="1.0" encoding="utf-8"?>
+<file path=ppt/notesSlides/notesSlide6.xml><?xml version="1.0" encoding="utf-8"?>
 <p:notes xmlns:a="http://schemas.openxmlformats.org/drawingml/2006/main" xmlns:r="http://schemas.openxmlformats.org/officeDocument/2006/relationships" xmlns:p="http://schemas.openxmlformats.org/presentationml/2006/main">
   <p:cSld>
     <p:spTree>
@@ -1470,7 +1388,7 @@
 </p:notes>
 </file>
 
-<file path=ppt/notesSlides/notesSlide8.xml><?xml version="1.0" encoding="utf-8"?>
+<file path=ppt/notesSlides/notesSlide7.xml><?xml version="1.0" encoding="utf-8"?>
 <p:notes xmlns:a="http://schemas.openxmlformats.org/drawingml/2006/main" xmlns:r="http://schemas.openxmlformats.org/officeDocument/2006/relationships" xmlns:p="http://schemas.openxmlformats.org/presentationml/2006/main">
   <p:cSld>
     <p:spTree>
@@ -1535,7 +1453,7 @@
           <a:p>
             <a:fld id="{A7839206-A81D-4F76-8486-302187992F73}" type="slidenum">
               <a:rPr lang="en-GB" smtClean="0"/>
-              <a:t>24</a:t>
+              <a:t>25</a:t>
             </a:fld>
             <a:endParaRPr lang="en-GB"/>
           </a:p>
@@ -6060,7 +5978,7 @@
         </p:spPr>
         <p:txBody>
           <a:bodyPr>
-            <a:normAutofit fontScale="92500" lnSpcReduction="10000"/>
+            <a:normAutofit fontScale="92500" lnSpcReduction="20000"/>
           </a:bodyPr>
           <a:lstStyle/>
           <a:p>
@@ -6090,7 +6008,7 @@
           <a:p>
             <a:r>
               <a:rPr lang="en-US" dirty="0"/>
-              <a:t>Each service performed a service (duh) for the engine</a:t>
+              <a:t>Each service performed a service for the engine</a:t>
             </a:r>
           </a:p>
           <a:p>
@@ -6126,6 +6044,12 @@
             <a:r>
               <a:rPr lang="en-US" dirty="0"/>
               <a:t>Type service (*)</a:t>
+            </a:r>
+          </a:p>
+          <a:p>
+            <a:r>
+              <a:rPr lang="en-US" dirty="0"/>
+              <a:t>Everything is Metadata driven</a:t>
             </a:r>
             <a:endParaRPr lang="en-GB" dirty="0"/>
           </a:p>
@@ -6145,7 +6069,7 @@
         </p:nvSpPr>
         <p:spPr>
           <a:xfrm>
-            <a:off x="10322286" y="4572000"/>
+            <a:off x="12098458" y="6506055"/>
             <a:ext cx="1869713" cy="2286000"/>
           </a:xfrm>
           <a:prstGeom prst="rect">
@@ -6321,7 +6245,7 @@
           <a:p>
             <a:r>
               <a:rPr lang="en-US" dirty="0"/>
-              <a:t>Using all these services made it hard to work with</a:t>
+              <a:t>Composing all these services made it hard to work with</a:t>
             </a:r>
           </a:p>
           <a:p>
@@ -6358,6 +6282,10 @@
           </a:p>
           <a:p>
             <a:pPr lvl="1"/>
+            <a:r>
+              <a:rPr lang="en-US" dirty="0"/>
+              <a:t>PowerShell </a:t>
+            </a:r>
             <a:r>
               <a:rPr lang="en-US" dirty="0" err="1"/>
               <a:t>RunSpace</a:t>
@@ -6678,7 +6606,7 @@
           <a:p>
             <a:r>
               <a:rPr lang="en-US" dirty="0"/>
-              <a:t>Declarative parameter specification (*) interpreted at runtime</a:t>
+              <a:t>Meta-data driven declarative parameter specification (*) interpreted at runtime</a:t>
             </a:r>
           </a:p>
           <a:p>
@@ -6691,7 +6619,7 @@
             <a:pPr lvl="1"/>
             <a:r>
               <a:rPr lang="en-US" dirty="0"/>
-              <a:t>Uses a bitmap to keep track of the still active sets.</a:t>
+              <a:t>Uses a 32 bit bitmap to keep track of the still active sets.</a:t>
             </a:r>
           </a:p>
           <a:p>
@@ -7056,7 +6984,7 @@
             </a:r>
             <a:r>
               <a:rPr lang="en-US" dirty="0"/>
-              <a:t> everything which means it flattens collections of collections by one level. (it’s essentially </a:t>
+              <a:t> everything which means it flattens collections of collections by one level. (i.e. it’s essentially </a:t>
             </a:r>
             <a:r>
               <a:rPr lang="en-US" i="1" dirty="0" err="1"/>
@@ -7391,7 +7319,12 @@
             <p:ph type="title"/>
           </p:nvPr>
         </p:nvSpPr>
-        <p:spPr/>
+        <p:spPr>
+          <a:xfrm>
+            <a:off x="546946" y="-102236"/>
+            <a:ext cx="9733280" cy="1325563"/>
+          </a:xfrm>
+        </p:spPr>
         <p:txBody>
           <a:bodyPr>
             <a:normAutofit/>
@@ -7423,13 +7356,13 @@
         </p:nvSpPr>
         <p:spPr>
           <a:xfrm>
-            <a:off x="892386" y="1524000"/>
-            <a:ext cx="10515600" cy="4721013"/>
+            <a:off x="452120" y="1223327"/>
+            <a:ext cx="10515600" cy="5319713"/>
           </a:xfrm>
         </p:spPr>
         <p:txBody>
           <a:bodyPr>
-            <a:normAutofit fontScale="92500" lnSpcReduction="20000"/>
+            <a:normAutofit lnSpcReduction="10000"/>
           </a:bodyPr>
           <a:lstStyle/>
           <a:p>
@@ -7458,21 +7391,7 @@
             <a:pPr lvl="1"/>
             <a:r>
               <a:rPr lang="en-US" dirty="0"/>
-              <a:t>We had a YACC grammar for a while, but PowerShell is not an LALR(1) language.</a:t>
-            </a:r>
-          </a:p>
-          <a:p>
-            <a:r>
-              <a:rPr lang="en-US" dirty="0"/>
-              <a:t>Design reset very early on to use (a subset of) C# (and also Java/</a:t>
-            </a:r>
-            <a:r>
-              <a:rPr lang="en-US" dirty="0" err="1"/>
-              <a:t>Javascript</a:t>
-            </a:r>
-            <a:r>
-              <a:rPr lang="en-US" dirty="0"/>
-              <a:t>/C/C++) because we wanted programmers to like PowerShell too.</a:t>
+              <a:t>Design reset very early on to use (a subset of) C# because we wanted programmers to like PowerShell too.</a:t>
             </a:r>
           </a:p>
           <a:p>
@@ -7484,7 +7403,18 @@
           <a:p>
             <a:r>
               <a:rPr lang="en-US" dirty="0"/>
-              <a:t>Single and double quoted strings, expansion, the quote character in strings backtick (`). People don’t like this.</a:t>
+              <a:t>Single and double quoted strings, string expansion, the quote character in strings backtick (`). People don’t like this.</a:t>
+            </a:r>
+            <a:endParaRPr lang="en-US" i="1" dirty="0"/>
+          </a:p>
+          <a:p>
+            <a:r>
+              <a:rPr lang="en-US" dirty="0" err="1"/>
+              <a:t>ScriptBlocks</a:t>
+            </a:r>
+            <a:r>
+              <a:rPr lang="en-US" dirty="0"/>
+              <a:t>, voidable statements, proxy functions</a:t>
             </a:r>
           </a:p>
           <a:p>
@@ -7492,6 +7422,7 @@
               <a:rPr lang="en-US" i="1" dirty="0"/>
               <a:t>Splatting hashtables instead of backquote. Humph</a:t>
             </a:r>
+            <a:endParaRPr lang="en-US" dirty="0"/>
           </a:p>
         </p:txBody>
       </p:sp>
@@ -7571,7 +7502,12 @@
             <p:ph idx="1"/>
           </p:nvPr>
         </p:nvSpPr>
-        <p:spPr/>
+        <p:spPr>
+          <a:xfrm>
+            <a:off x="838200" y="1690688"/>
+            <a:ext cx="10515600" cy="4351338"/>
+          </a:xfrm>
+        </p:spPr>
         <p:txBody>
           <a:bodyPr>
             <a:normAutofit lnSpcReduction="10000"/>
@@ -7743,10 +7679,15 @@
             <p:ph idx="1"/>
           </p:nvPr>
         </p:nvSpPr>
-        <p:spPr/>
+        <p:spPr>
+          <a:xfrm>
+            <a:off x="750147" y="1554691"/>
+            <a:ext cx="10515600" cy="4676775"/>
+          </a:xfrm>
+        </p:spPr>
         <p:txBody>
           <a:bodyPr>
-            <a:normAutofit/>
+            <a:normAutofit fontScale="92500" lnSpcReduction="10000"/>
           </a:bodyPr>
           <a:lstStyle/>
           <a:p>
@@ -7759,7 +7700,14 @@
             <a:pPr lvl="1"/>
             <a:r>
               <a:rPr lang="en-US" dirty="0"/>
-              <a:t> numbers(!), strings, arrays(!) and hashtables</a:t>
+              <a:t>Numbers(!), strings, arrays(!) and hashtables</a:t>
+            </a:r>
+          </a:p>
+          <a:p>
+            <a:pPr lvl="1"/>
+            <a:r>
+              <a:rPr lang="en-US" dirty="0"/>
+              <a:t>Boolean (true &amp; false)</a:t>
             </a:r>
           </a:p>
           <a:p>
@@ -7801,7 +7749,11 @@
             </a:r>
             <a:r>
               <a:rPr lang="en-US" dirty="0"/>
-              <a:t> conversions always applied everywhere</a:t>
+              <a:t> conversions always </a:t>
+            </a:r>
+            <a:r>
+              <a:rPr lang="en-US" i="1" dirty="0"/>
+              <a:t>applied everywhere</a:t>
             </a:r>
           </a:p>
           <a:p>
@@ -7809,6 +7761,21 @@
             <a:r>
               <a:rPr lang="en-US" dirty="0"/>
               <a:t>No stupid or partial conversions to help prevent data loss.</a:t>
+            </a:r>
+          </a:p>
+          <a:p>
+            <a:pPr lvl="1"/>
+            <a:r>
+              <a:rPr lang="en-US" dirty="0"/>
+              <a:t>Is ‘0025’ on the </a:t>
+            </a:r>
+            <a:r>
+              <a:rPr lang="en-US" dirty="0" err="1"/>
+              <a:t>cmd</a:t>
+            </a:r>
+            <a:r>
+              <a:rPr lang="en-US" dirty="0"/>
+              <a:t> line a string or an integer? </a:t>
             </a:r>
           </a:p>
         </p:txBody>
@@ -7923,7 +7890,7 @@
             <a:pPr lvl="1"/>
             <a:r>
               <a:rPr lang="en-US" sz="2400" dirty="0"/>
-              <a:t>Terminating and non-terminating errors, $?, $LASTEXITCODE</a:t>
+              <a:t>Terminating and non-terminating errors, exceptions, $?, $LASTEXITCODE</a:t>
             </a:r>
           </a:p>
           <a:p>
@@ -7937,7 +7904,7 @@
             <a:pPr lvl="1"/>
             <a:r>
               <a:rPr lang="en-US" sz="2400" dirty="0"/>
-              <a:t>We had the idea of restarting an operation based on the error objects but as far as I know, this is not used</a:t>
+              <a:t>Non-terminating errors allowed the idea of restarting an operation based on the error objects but as far as I know, this is not used</a:t>
             </a:r>
           </a:p>
           <a:p>
@@ -7967,7 +7934,7 @@
           <a:p>
             <a:r>
               <a:rPr lang="en-US" sz="2800" dirty="0"/>
-              <a:t>Handling errors</a:t>
+              <a:t>Handling errors and exceptions</a:t>
             </a:r>
           </a:p>
           <a:p>
@@ -8248,8 +8215,12 @@
           </a:p>
           <a:p>
             <a:r>
+              <a:rPr lang="en-US" i="1" dirty="0"/>
+              <a:t>Language</a:t>
+            </a:r>
+            <a:r>
               <a:rPr lang="en-US" dirty="0"/>
-              <a:t>The language runtime was sped up about 10x with the DLR work but…</a:t>
+              <a:t> execution was sped up about 10x with the DLR work but…</a:t>
             </a:r>
           </a:p>
           <a:p>
@@ -8270,14 +8241,14 @@
             </a:r>
             <a:r>
               <a:rPr lang="en-US" dirty="0"/>
-              <a:t> object that is processed</a:t>
+              <a:t> object that’s processed resulting in lots of allocations</a:t>
             </a:r>
           </a:p>
           <a:p>
             <a:pPr lvl="1"/>
             <a:r>
               <a:rPr lang="en-US" dirty="0"/>
-              <a:t>Returns a collection of PSObjects resulting in many unnecessary allocations</a:t>
+              <a:t>Returns a collection of (weak ref) PSObjects resulting in even more unnecessary allocations</a:t>
             </a:r>
           </a:p>
           <a:p>
@@ -8302,6 +8273,185 @@
 </file>
 
 <file path=ppt/slides/slide21.xml><?xml version="1.0" encoding="utf-8"?>
+<p:sld xmlns:a="http://schemas.openxmlformats.org/drawingml/2006/main" xmlns:r="http://schemas.openxmlformats.org/officeDocument/2006/relationships" xmlns:p="http://schemas.openxmlformats.org/presentationml/2006/main">
+  <p:cSld>
+    <p:spTree>
+      <p:nvGrpSpPr>
+        <p:cNvPr id="1" name=""/>
+        <p:cNvGrpSpPr/>
+        <p:nvPr/>
+      </p:nvGrpSpPr>
+      <p:grpSpPr>
+        <a:xfrm>
+          <a:off x="0" y="0"/>
+          <a:ext cx="0" cy="0"/>
+          <a:chOff x="0" y="0"/>
+          <a:chExt cx="0" cy="0"/>
+        </a:xfrm>
+      </p:grpSpPr>
+      <p:sp>
+        <p:nvSpPr>
+          <p:cNvPr id="2" name="Title 1">
+            <a:extLst>
+              <a:ext uri="{FF2B5EF4-FFF2-40B4-BE49-F238E27FC236}">
+                <a16:creationId xmlns:a16="http://schemas.microsoft.com/office/drawing/2014/main" id="{B87AFA3B-5A3F-2D6B-96E6-37B826603DF3}"/>
+              </a:ext>
+            </a:extLst>
+          </p:cNvPr>
+          <p:cNvSpPr>
+            <a:spLocks noGrp="1"/>
+          </p:cNvSpPr>
+          <p:nvPr>
+            <p:ph type="title"/>
+          </p:nvPr>
+        </p:nvSpPr>
+        <p:spPr>
+          <a:xfrm>
+            <a:off x="759259" y="88833"/>
+            <a:ext cx="9733280" cy="1325563"/>
+          </a:xfrm>
+        </p:spPr>
+        <p:txBody>
+          <a:bodyPr/>
+          <a:lstStyle/>
+          <a:p>
+            <a:r>
+              <a:rPr lang="en-US" dirty="0"/>
+              <a:t>Other Stuff</a:t>
+            </a:r>
+          </a:p>
+        </p:txBody>
+      </p:sp>
+      <p:sp>
+        <p:nvSpPr>
+          <p:cNvPr id="3" name="Content Placeholder 2">
+            <a:extLst>
+              <a:ext uri="{FF2B5EF4-FFF2-40B4-BE49-F238E27FC236}">
+                <a16:creationId xmlns:a16="http://schemas.microsoft.com/office/drawing/2014/main" id="{CA95AC93-D038-EA0C-EF6F-D3029E9A2D64}"/>
+              </a:ext>
+            </a:extLst>
+          </p:cNvPr>
+          <p:cNvSpPr>
+            <a:spLocks noGrp="1"/>
+          </p:cNvSpPr>
+          <p:nvPr>
+            <p:ph idx="1"/>
+          </p:nvPr>
+        </p:nvSpPr>
+        <p:spPr>
+          <a:xfrm>
+            <a:off x="838200" y="1276213"/>
+            <a:ext cx="10515600" cy="4979691"/>
+          </a:xfrm>
+        </p:spPr>
+        <p:txBody>
+          <a:bodyPr>
+            <a:normAutofit fontScale="85000" lnSpcReduction="10000"/>
+          </a:bodyPr>
+          <a:lstStyle/>
+          <a:p>
+            <a:r>
+              <a:rPr lang="en-US" dirty="0"/>
+              <a:t>Domain Specific Vocabularies</a:t>
+            </a:r>
+          </a:p>
+          <a:p>
+            <a:pPr lvl="1"/>
+            <a:r>
+              <a:rPr lang="en-US" dirty="0"/>
+              <a:t>vs Domain Specific Languages</a:t>
+            </a:r>
+          </a:p>
+          <a:p>
+            <a:r>
+              <a:rPr lang="en-US" dirty="0"/>
+              <a:t>Presentation Name vs Concrete Name</a:t>
+            </a:r>
+          </a:p>
+          <a:p>
+            <a:r>
+              <a:rPr lang="en-US" dirty="0"/>
+              <a:t>Classes</a:t>
+            </a:r>
+          </a:p>
+          <a:p>
+            <a:pPr lvl="1"/>
+            <a:r>
+              <a:rPr lang="en-US" dirty="0"/>
+              <a:t>Goal: “Python complete” (but with ‘hidden’ members)</a:t>
+            </a:r>
+          </a:p>
+          <a:p>
+            <a:pPr lvl="1"/>
+            <a:r>
+              <a:rPr lang="en-US" dirty="0"/>
+              <a:t>Early bound</a:t>
+            </a:r>
+          </a:p>
+          <a:p>
+            <a:r>
+              <a:rPr lang="en-US" dirty="0"/>
+              <a:t>Result of *every* statement goes to output</a:t>
+            </a:r>
+          </a:p>
+          <a:p>
+            <a:pPr lvl="1"/>
+            <a:r>
+              <a:rPr lang="en-US" dirty="0"/>
+              <a:t>Instead of only the last statement in the block (like Braid)</a:t>
+            </a:r>
+          </a:p>
+          <a:p>
+            <a:r>
+              <a:rPr lang="en-US" dirty="0"/>
+              <a:t>Principle: never automatically turn text into code</a:t>
+            </a:r>
+          </a:p>
+          <a:p>
+            <a:pPr lvl="1"/>
+            <a:r>
+              <a:rPr lang="en-US" dirty="0"/>
+              <a:t>Except for $</a:t>
+            </a:r>
+            <a:r>
+              <a:rPr lang="en-US" dirty="0" err="1"/>
+              <a:t>function:foo</a:t>
+            </a:r>
+            <a:r>
+              <a:rPr lang="en-US" dirty="0"/>
+              <a:t> = ‘$_ * 2’</a:t>
+            </a:r>
+          </a:p>
+          <a:p>
+            <a:r>
+              <a:rPr lang="en-US" dirty="0"/>
+              <a:t>Commands calling commands (splatting, </a:t>
+            </a:r>
+            <a:r>
+              <a:rPr lang="en-US" dirty="0" err="1"/>
+              <a:t>PSBoundParameter</a:t>
+            </a:r>
+            <a:r>
+              <a:rPr lang="en-US" dirty="0"/>
+              <a:t>)</a:t>
+            </a:r>
+          </a:p>
+        </p:txBody>
+      </p:sp>
+    </p:spTree>
+    <p:extLst>
+      <p:ext uri="{BB962C8B-B14F-4D97-AF65-F5344CB8AC3E}">
+        <p14:creationId xmlns:p14="http://schemas.microsoft.com/office/powerpoint/2010/main" val="1540290413"/>
+      </p:ext>
+    </p:extLst>
+  </p:cSld>
+  <p:clrMapOvr>
+    <a:masterClrMapping/>
+  </p:clrMapOvr>
+</p:sld>
+</file>
+
+<file path=ppt/slides/slide22.xml><?xml version="1.0" encoding="utf-8"?>
 <p:sld xmlns:a="http://schemas.openxmlformats.org/drawingml/2006/main" xmlns:r="http://schemas.openxmlformats.org/officeDocument/2006/relationships" xmlns:p="http://schemas.openxmlformats.org/presentationml/2006/main">
   <p:cSld>
     <p:spTree>
@@ -8391,7 +8541,7 @@
           <a:p>
             <a:r>
               <a:rPr lang="en-US" dirty="0"/>
-              <a:t>During Longhorn/Vista, Windows Management said “No Extensibility, No Plugins” due to concerns about reliability and versioning.</a:t>
+              <a:t>During Longhorn/Vista, Windows Core Architecture said “No Extensibility, No Plugins” due to concerns about reliability and versioning.</a:t>
             </a:r>
           </a:p>
           <a:p>
@@ -8473,7 +8623,7 @@
 </p:sld>
 </file>
 
-<file path=ppt/slides/slide22.xml><?xml version="1.0" encoding="utf-8"?>
+<file path=ppt/slides/slide23.xml><?xml version="1.0" encoding="utf-8"?>
 <p:sld xmlns:a="http://schemas.openxmlformats.org/drawingml/2006/main" xmlns:r="http://schemas.openxmlformats.org/officeDocument/2006/relationships" xmlns:p="http://schemas.openxmlformats.org/presentationml/2006/main">
   <p:cSld>
     <p:spTree>
@@ -8543,7 +8693,7 @@
           <a:p>
             <a:r>
               <a:rPr lang="en-US" dirty="0"/>
-              <a:t>Overall rating 3.6/5</a:t>
+              <a:t>Overall rating ~3.6/5</a:t>
             </a:r>
           </a:p>
           <a:p>
@@ -8573,7 +8723,7 @@
 </p:sld>
 </file>
 
-<file path=ppt/slides/slide23.xml><?xml version="1.0" encoding="utf-8"?>
+<file path=ppt/slides/slide24.xml><?xml version="1.0" encoding="utf-8"?>
 <p:sld xmlns:a="http://schemas.openxmlformats.org/drawingml/2006/main" xmlns:r="http://schemas.openxmlformats.org/officeDocument/2006/relationships" xmlns:p="http://schemas.openxmlformats.org/presentationml/2006/main">
   <p:cSld>
     <p:spTree>
@@ -8914,7 +9064,7 @@
 </p:sld>
 </file>
 
-<file path=ppt/slides/slide24.xml><?xml version="1.0" encoding="utf-8"?>
+<file path=ppt/slides/slide25.xml><?xml version="1.0" encoding="utf-8"?>
 <p:sld xmlns:a="http://schemas.openxmlformats.org/drawingml/2006/main" xmlns:r="http://schemas.openxmlformats.org/officeDocument/2006/relationships" xmlns:p="http://schemas.openxmlformats.org/presentationml/2006/main">
   <p:cSld>
     <p:spTree>
@@ -9670,119 +9820,12 @@
           <a:chExt cx="0" cy="0"/>
         </a:xfrm>
       </p:grpSpPr>
-      <p:sp>
-        <p:nvSpPr>
-          <p:cNvPr id="4" name="Titel 3">
+      <p:pic>
+        <p:nvPicPr>
+          <p:cNvPr id="2" name="Graphique 6">
             <a:extLst>
               <a:ext uri="{FF2B5EF4-FFF2-40B4-BE49-F238E27FC236}">
-                <a16:creationId xmlns:a16="http://schemas.microsoft.com/office/drawing/2014/main" id="{D531CB4D-40EE-4CEA-4C1F-A86C158A8A50}"/>
-              </a:ext>
-            </a:extLst>
-          </p:cNvPr>
-          <p:cNvSpPr>
-            <a:spLocks noGrp="1"/>
-          </p:cNvSpPr>
-          <p:nvPr>
-            <p:ph type="title" idx="4294967295"/>
-          </p:nvPr>
-        </p:nvSpPr>
-        <p:spPr>
-          <a:xfrm>
-            <a:off x="1009061" y="630961"/>
-            <a:ext cx="9733280" cy="1325563"/>
-          </a:xfrm>
-        </p:spPr>
-        <p:txBody>
-          <a:bodyPr/>
-          <a:lstStyle/>
-          <a:p>
-            <a:pPr rtl="0" eaLnBrk="1" latinLnBrk="0" hangingPunct="1"/>
-            <a:r>
-              <a:rPr lang="fr-FR" sz="4000" b="1" kern="1200" err="1">
-                <a:solidFill>
-                  <a:srgbClr val="3B2A47"/>
-                </a:solidFill>
-                <a:effectLst/>
-                <a:latin typeface="Calibri" panose="020F0502020204030204" pitchFamily="34" charset="0"/>
-                <a:ea typeface="+mn-ea"/>
-                <a:cs typeface="+mn-cs"/>
-              </a:rPr>
-              <a:t>Many</a:t>
-            </a:r>
-            <a:r>
-              <a:rPr lang="fr-FR" sz="4000" b="1" kern="1200">
-                <a:solidFill>
-                  <a:srgbClr val="3B2A47"/>
-                </a:solidFill>
-                <a:effectLst/>
-                <a:latin typeface="Calibri" panose="020F0502020204030204" pitchFamily="34" charset="0"/>
-                <a:ea typeface="+mn-ea"/>
-                <a:cs typeface="+mn-cs"/>
-              </a:rPr>
-              <a:t> </a:t>
-            </a:r>
-            <a:r>
-              <a:rPr lang="fr-FR" sz="4000" b="1" kern="1200" err="1">
-                <a:solidFill>
-                  <a:srgbClr val="3B2A47"/>
-                </a:solidFill>
-                <a:effectLst/>
-                <a:latin typeface="Calibri" panose="020F0502020204030204" pitchFamily="34" charset="0"/>
-                <a:ea typeface="+mn-ea"/>
-                <a:cs typeface="+mn-cs"/>
-              </a:rPr>
-              <a:t>thanks</a:t>
-            </a:r>
-            <a:r>
-              <a:rPr lang="fr-FR" sz="4000" b="1" kern="1200">
-                <a:solidFill>
-                  <a:srgbClr val="3B2A47"/>
-                </a:solidFill>
-                <a:effectLst/>
-                <a:latin typeface="Calibri" panose="020F0502020204030204" pitchFamily="34" charset="0"/>
-                <a:ea typeface="+mn-ea"/>
-                <a:cs typeface="+mn-cs"/>
-              </a:rPr>
-              <a:t> to </a:t>
-            </a:r>
-            <a:r>
-              <a:rPr lang="fr-FR" sz="4000" b="1" kern="1200" err="1">
-                <a:solidFill>
-                  <a:srgbClr val="3B2A47"/>
-                </a:solidFill>
-                <a:effectLst/>
-                <a:latin typeface="Calibri" panose="020F0502020204030204" pitchFamily="34" charset="0"/>
-                <a:ea typeface="+mn-ea"/>
-                <a:cs typeface="+mn-cs"/>
-              </a:rPr>
-              <a:t>our</a:t>
-            </a:r>
-            <a:r>
-              <a:rPr lang="fr-FR" sz="4000" b="1" kern="1200">
-                <a:solidFill>
-                  <a:srgbClr val="3B2A47"/>
-                </a:solidFill>
-                <a:effectLst/>
-                <a:latin typeface="Calibri" panose="020F0502020204030204" pitchFamily="34" charset="0"/>
-                <a:ea typeface="+mn-ea"/>
-                <a:cs typeface="+mn-cs"/>
-              </a:rPr>
-              <a:t> sponsors:</a:t>
-            </a:r>
-            <a:endParaRPr lang="en-DE">
-              <a:solidFill>
-                <a:srgbClr val="3B2A47"/>
-              </a:solidFill>
-            </a:endParaRPr>
-          </a:p>
-        </p:txBody>
-      </p:sp>
-      <p:pic>
-        <p:nvPicPr>
-          <p:cNvPr id="8" name="Graphique 7">
-            <a:extLst>
-              <a:ext uri="{FF2B5EF4-FFF2-40B4-BE49-F238E27FC236}">
-                <a16:creationId xmlns:a16="http://schemas.microsoft.com/office/drawing/2014/main" id="{C4BDF3A9-64A1-2EA9-AABD-6B9AFBACBB04}"/>
+                <a16:creationId xmlns:a16="http://schemas.microsoft.com/office/drawing/2014/main" id="{56B20C8F-B2CB-B1F9-8E7F-3897FE369D5D}"/>
               </a:ext>
             </a:extLst>
           </p:cNvPr>
@@ -9795,7 +9838,7 @@
           <a:blip>
             <a:extLst>
               <a:ext uri="{96DAC541-7B7A-43D3-8B79-37D633B846F1}">
-                <asvg:svgBlip xmlns:asvg="http://schemas.microsoft.com/office/drawing/2016/SVG/main" r:embed="rId3"/>
+                <asvg:svgBlip xmlns:asvg="http://schemas.microsoft.com/office/drawing/2016/SVG/main" r:embed="rId2"/>
               </a:ext>
             </a:extLst>
           </a:blip>
@@ -9805,18 +9848,128 @@
         </p:blipFill>
         <p:spPr>
           <a:xfrm>
-            <a:off x="1542212" y="2028538"/>
-            <a:ext cx="8666978" cy="3146276"/>
+            <a:off x="1380963" y="2327350"/>
+            <a:ext cx="8666977" cy="2650633"/>
           </a:xfrm>
           <a:prstGeom prst="rect">
             <a:avLst/>
           </a:prstGeom>
         </p:spPr>
       </p:pic>
+      <p:sp>
+        <p:nvSpPr>
+          <p:cNvPr id="3" name="Titel 3">
+            <a:extLst>
+              <a:ext uri="{FF2B5EF4-FFF2-40B4-BE49-F238E27FC236}">
+                <a16:creationId xmlns:a16="http://schemas.microsoft.com/office/drawing/2014/main" id="{E8D5F61D-8E53-AAB9-82E3-4B5C178B574B}"/>
+              </a:ext>
+            </a:extLst>
+          </p:cNvPr>
+          <p:cNvSpPr txBox="1">
+            <a:spLocks/>
+          </p:cNvSpPr>
+          <p:nvPr/>
+        </p:nvSpPr>
+        <p:spPr>
+          <a:xfrm>
+            <a:off x="1101159" y="630961"/>
+            <a:ext cx="9733280" cy="1325563"/>
+          </a:xfrm>
+          <a:prstGeom prst="rect">
+            <a:avLst/>
+          </a:prstGeom>
+        </p:spPr>
+        <p:txBody>
+          <a:bodyPr vert="horz" lIns="91440" tIns="45720" rIns="91440" bIns="45720" rtlCol="0" anchor="ctr">
+            <a:normAutofit/>
+          </a:bodyPr>
+          <a:lstStyle>
+            <a:lvl1pPr algn="l" defTabSz="914400" rtl="0" eaLnBrk="1" latinLnBrk="0" hangingPunct="1">
+              <a:lnSpc>
+                <a:spcPct val="90000"/>
+              </a:lnSpc>
+              <a:spcBef>
+                <a:spcPct val="0"/>
+              </a:spcBef>
+              <a:buNone/>
+              <a:defRPr sz="5400" b="1" kern="1200">
+                <a:solidFill>
+                  <a:srgbClr val="3B2B46"/>
+                </a:solidFill>
+                <a:latin typeface="+mj-lt"/>
+                <a:ea typeface="+mj-ea"/>
+                <a:cs typeface="+mj-cs"/>
+              </a:defRPr>
+            </a:lvl1pPr>
+          </a:lstStyle>
+          <a:p>
+            <a:r>
+              <a:rPr lang="fr-FR" sz="4000" dirty="0">
+                <a:solidFill>
+                  <a:srgbClr val="3B2A47"/>
+                </a:solidFill>
+                <a:latin typeface="Calibri" panose="020F0502020204030204" pitchFamily="34" charset="0"/>
+                <a:ea typeface="+mn-ea"/>
+                <a:cs typeface="+mn-cs"/>
+              </a:rPr>
+              <a:t>Many </a:t>
+            </a:r>
+            <a:r>
+              <a:rPr lang="fr-FR" sz="4000" dirty="0" err="1">
+                <a:solidFill>
+                  <a:srgbClr val="3B2A47"/>
+                </a:solidFill>
+                <a:latin typeface="Calibri" panose="020F0502020204030204" pitchFamily="34" charset="0"/>
+                <a:ea typeface="+mn-ea"/>
+                <a:cs typeface="+mn-cs"/>
+              </a:rPr>
+              <a:t>thanks</a:t>
+            </a:r>
+            <a:r>
+              <a:rPr lang="fr-FR" sz="4000" dirty="0">
+                <a:solidFill>
+                  <a:srgbClr val="3B2A47"/>
+                </a:solidFill>
+                <a:latin typeface="Calibri" panose="020F0502020204030204" pitchFamily="34" charset="0"/>
+                <a:ea typeface="+mn-ea"/>
+                <a:cs typeface="+mn-cs"/>
+              </a:rPr>
+              <a:t> to </a:t>
+            </a:r>
+            <a:r>
+              <a:rPr lang="fr-FR" sz="4000" dirty="0" err="1">
+                <a:solidFill>
+                  <a:srgbClr val="3B2A47"/>
+                </a:solidFill>
+                <a:latin typeface="Calibri" panose="020F0502020204030204" pitchFamily="34" charset="0"/>
+                <a:ea typeface="+mn-ea"/>
+                <a:cs typeface="+mn-cs"/>
+              </a:rPr>
+              <a:t>our</a:t>
+            </a:r>
+            <a:r>
+              <a:rPr lang="fr-FR" sz="4000" dirty="0">
+                <a:solidFill>
+                  <a:srgbClr val="3B2A47"/>
+                </a:solidFill>
+                <a:latin typeface="Calibri" panose="020F0502020204030204" pitchFamily="34" charset="0"/>
+                <a:ea typeface="+mn-ea"/>
+                <a:cs typeface="+mn-cs"/>
+              </a:rPr>
+              <a:t> sponsors:</a:t>
+            </a:r>
+            <a:endParaRPr lang="en-DE" dirty="0">
+              <a:solidFill>
+                <a:srgbClr val="3B2A47"/>
+              </a:solidFill>
+            </a:endParaRPr>
+          </a:p>
+        </p:txBody>
+      </p:sp>
     </p:spTree>
     <p:extLst>
       <p:ext uri="{BB962C8B-B14F-4D97-AF65-F5344CB8AC3E}">
-        <p14:creationId xmlns:p14="http://schemas.microsoft.com/office/powerpoint/2010/main" val="3984835757"/>
+        <p14:creationId xmlns:p14="http://schemas.microsoft.com/office/powerpoint/2010/main" val="3387779289"/>
       </p:ext>
     </p:extLst>
   </p:cSld>
@@ -10227,7 +10380,9 @@
           </a:xfrm>
         </p:spPr>
         <p:txBody>
-          <a:bodyPr/>
+          <a:bodyPr>
+            <a:normAutofit lnSpcReduction="10000"/>
+          </a:bodyPr>
           <a:lstStyle/>
           <a:p>
             <a:r>
@@ -10249,7 +10404,18 @@
           <a:p>
             <a:r>
               <a:rPr lang="en-US" dirty="0"/>
-              <a:t>Examining individual scenarios</a:t>
+              <a:t>Examining individual components and scenarios</a:t>
+            </a:r>
+          </a:p>
+          <a:p>
+            <a:pPr lvl="1"/>
+            <a:r>
+              <a:rPr lang="en-US" dirty="0">
+                <a:solidFill>
+                  <a:schemeClr val="accent1"/>
+                </a:solidFill>
+              </a:rPr>
+              <a:t>Can’t possibly cover everything (20 years!!!)</a:t>
             </a:r>
           </a:p>
           <a:p>
@@ -10275,6 +10441,17 @@
             </a:r>
           </a:p>
           <a:p>
+            <a:pPr lvl="1"/>
+            <a:r>
+              <a:rPr lang="en-US" dirty="0">
+                <a:solidFill>
+                  <a:schemeClr val="accent1"/>
+                </a:solidFill>
+              </a:rPr>
+              <a:t>Not throwing rocks but maybe a few pebbles?</a:t>
+            </a:r>
+          </a:p>
+          <a:p>
             <a:r>
               <a:rPr lang="en-US" dirty="0"/>
               <a:t>Conclusions</a:t>
@@ -10285,6 +10462,9 @@
               <a:rPr lang="en-US" dirty="0"/>
               <a:t>Q &amp; A</a:t>
             </a:r>
+          </a:p>
+          <a:p>
+            <a:endParaRPr lang="en-US" dirty="0"/>
           </a:p>
           <a:p>
             <a:pPr lvl="1"/>
@@ -10451,15 +10631,21 @@
           <a:p>
             <a:r>
               <a:rPr lang="en-US" sz="2400" dirty="0"/>
-              <a:t>Deep simplicity and deep consistency are king (at least for the </a:t>
-            </a:r>
-            <a:r>
-              <a:rPr lang="en-US" sz="2400" dirty="0" err="1"/>
-              <a:t>ITPro</a:t>
-            </a:r>
+              <a:t>Deep simplicity and deep consistency for a diverse audience</a:t>
+            </a:r>
+          </a:p>
+          <a:p>
+            <a:pPr lvl="1"/>
             <a:r>
               <a:rPr lang="en-US" sz="2400" dirty="0"/>
-              <a:t> user)</a:t>
+              <a:t>Consistent strong naming guidelines, especially for verbs, no plurals</a:t>
+            </a:r>
+          </a:p>
+          <a:p>
+            <a:pPr lvl="1"/>
+            <a:r>
+              <a:rPr lang="en-US" sz="2400" dirty="0"/>
+              <a:t>Reflection, introspection and metadata</a:t>
             </a:r>
           </a:p>
           <a:p>
@@ -10470,11 +10656,11 @@
             </a:r>
             <a:r>
               <a:rPr lang="en-US" sz="2400" i="1" dirty="0"/>
-              <a:t>foolish consistency</a:t>
+              <a:t>foolish consistency”, </a:t>
             </a:r>
             <a:r>
               <a:rPr lang="en-US" sz="2400" dirty="0"/>
-              <a:t>”. It is possible to over do consistency/simplicity – works in the general case, fails in edge scenarios. Examples:</a:t>
+              <a:t>for example:</a:t>
             </a:r>
           </a:p>
           <a:p>
@@ -10556,7 +10742,7 @@
             <a:pPr lvl="1"/>
             <a:r>
               <a:rPr lang="en-US" sz="2400" dirty="0"/>
-              <a:t>Backwards compatibility is super important. </a:t>
+              <a:t>Makes backwards compatibility is super important. </a:t>
             </a:r>
           </a:p>
         </p:txBody>
@@ -12478,15 +12664,6 @@
 </file>
 
 <file path=customXml/item2.xml><?xml version="1.0" encoding="utf-8"?>
-<?mso-contentType ?>
-<FormTemplates xmlns="http://schemas.microsoft.com/sharepoint/v3/contenttype/forms">
-  <Display>DocumentLibraryForm</Display>
-  <Edit>DocumentLibraryForm</Edit>
-  <New>DocumentLibraryForm</New>
-</FormTemplates>
-</file>
-
-<file path=customXml/item3.xml><?xml version="1.0" encoding="utf-8"?>
 <p:properties xmlns:p="http://schemas.microsoft.com/office/2006/metadata/properties" xmlns:xsi="http://www.w3.org/2001/XMLSchema-instance" xmlns:pc="http://schemas.microsoft.com/office/infopath/2007/PartnerControls">
   <documentManagement>
     <lcf76f155ced4ddcb4097134ff3c332f xmlns="abdc9a1f-962e-4235-838d-61f9c438f4db">
@@ -12495,6 +12672,15 @@
     <TaxCatchAll xmlns="de47e97d-64fd-4aef-b10e-fd7d6cfcfcf4" xsi:nil="true"/>
   </documentManagement>
 </p:properties>
+</file>
+
+<file path=customXml/item3.xml><?xml version="1.0" encoding="utf-8"?>
+<?mso-contentType ?>
+<FormTemplates xmlns="http://schemas.microsoft.com/sharepoint/v3/contenttype/forms">
+  <Display>DocumentLibraryForm</Display>
+  <Edit>DocumentLibraryForm</Edit>
+  <New>DocumentLibraryForm</New>
+</FormTemplates>
 </file>
 
 <file path=customXml/itemProps1.xml><?xml version="1.0" encoding="utf-8"?>
@@ -12517,14 +12703,6 @@
 </file>
 
 <file path=customXml/itemProps2.xml><?xml version="1.0" encoding="utf-8"?>
-<ds:datastoreItem xmlns:ds="http://schemas.openxmlformats.org/officeDocument/2006/customXml" ds:itemID="{57D9B22B-F436-4FE5-B6C0-65AB2260F593}">
-  <ds:schemaRefs>
-    <ds:schemaRef ds:uri="http://schemas.microsoft.com/sharepoint/v3/contenttype/forms"/>
-  </ds:schemaRefs>
-</ds:datastoreItem>
-</file>
-
-<file path=customXml/itemProps3.xml><?xml version="1.0" encoding="utf-8"?>
 <ds:datastoreItem xmlns:ds="http://schemas.openxmlformats.org/officeDocument/2006/customXml" ds:itemID="{AA9C06E3-346E-408E-B352-32E922A070CE}">
   <ds:schemaRefs>
     <ds:schemaRef ds:uri="2347cc20-e10c-452d-848a-c18e83138525"/>
@@ -12537,4 +12715,12 @@
     <ds:schemaRef ds:uri="http://schemas.microsoft.com/office/infopath/2007/PartnerControls"/>
   </ds:schemaRefs>
 </ds:datastoreItem>
+</file>
+
+<file path=customXml/itemProps3.xml><?xml version="1.0" encoding="utf-8"?>
+<ds:datastoreItem xmlns:ds="http://schemas.openxmlformats.org/officeDocument/2006/customXml" ds:itemID="{57D9B22B-F436-4FE5-B6C0-65AB2260F593}">
+  <ds:schemaRefs>
+    <ds:schemaRef ds:uri="http://schemas.microsoft.com/sharepoint/v3/contenttype/forms"/>
+  </ds:schemaRefs>
+</ds:datastoreItem>
 </file>
</xml_diff>

<commit_message>
Post PSConf.EU presentation changes
</commit_message>
<xml_diff>
--- a/PSCONF26_Payette_Designing_PowerShell.pptx
+++ b/PSCONF26_Payette_Designing_PowerShell.pptx
@@ -6036,7 +6036,7 @@
             <a:pPr lvl="1"/>
             <a:r>
               <a:rPr lang="en-US" dirty="0"/>
-              <a:t>Language service</a:t>
+              <a:t>Language service </a:t>
             </a:r>
           </a:p>
           <a:p>
@@ -6049,7 +6049,7 @@
           <a:p>
             <a:r>
               <a:rPr lang="en-US" dirty="0"/>
-              <a:t>Everything is Metadata driven</a:t>
+              <a:t>Everything is declarative Metadata driven (*)</a:t>
             </a:r>
             <a:endParaRPr lang="en-GB" dirty="0"/>
           </a:p>
@@ -6252,7 +6252,7 @@
             <a:pPr lvl="1"/>
             <a:r>
               <a:rPr lang="en-US" dirty="0"/>
-              <a:t>LEGO shell?</a:t>
+              <a:t>LEGO shell? Nah.</a:t>
             </a:r>
           </a:p>
           <a:p>
@@ -6292,7 +6292,7 @@
             </a:r>
             <a:r>
               <a:rPr lang="en-US" dirty="0"/>
-              <a:t> == “A place to run PowerShell code”</a:t>
+              <a:t> == “A space to run PowerShell code”</a:t>
             </a:r>
           </a:p>
         </p:txBody>
@@ -6405,26 +6405,13 @@
           <a:p>
             <a:r>
               <a:rPr lang="en-US" dirty="0"/>
-              <a:t>Initially, users would connect to a remote </a:t>
-            </a:r>
-            <a:r>
-              <a:rPr lang="en-US" dirty="0" err="1"/>
-              <a:t>RunSpace</a:t>
-            </a:r>
-            <a:endParaRPr lang="en-US" dirty="0"/>
+              <a:t>Initially, users would connect to a remote Runspace</a:t>
+            </a:r>
           </a:p>
           <a:p>
             <a:r>
               <a:rPr lang="en-US" dirty="0"/>
-              <a:t>BUT when the usability folks tested this, they found that users thought “</a:t>
-            </a:r>
-            <a:r>
-              <a:rPr lang="en-US" dirty="0" err="1"/>
-              <a:t>RunSpace</a:t>
-            </a:r>
-            <a:r>
-              <a:rPr lang="en-US" dirty="0"/>
-              <a:t>” was confusing and preferred “Session” which was already a familiar term.</a:t>
+              <a:t>BUT when the usability folks tested this, they found that users thought “Runspace” was confusing and preferred “Session” which was already a familiar term.</a:t>
             </a:r>
           </a:p>
           <a:p>
@@ -6437,15 +6424,7 @@
             <a:pPr lvl="1"/>
             <a:r>
               <a:rPr lang="en-US" dirty="0"/>
-              <a:t>The ideal(?) fix would’ve been to change </a:t>
-            </a:r>
-            <a:r>
-              <a:rPr lang="en-US" dirty="0" err="1"/>
-              <a:t>RunSpace</a:t>
-            </a:r>
-            <a:r>
-              <a:rPr lang="en-US" dirty="0"/>
-              <a:t> to Session</a:t>
+              <a:t>The ideal(?) fix would’ve been to change Runspace to Session</a:t>
             </a:r>
           </a:p>
           <a:p>
@@ -6606,7 +6585,7 @@
           <a:p>
             <a:r>
               <a:rPr lang="en-US" dirty="0"/>
-              <a:t>Meta-data driven declarative parameter specification (*) interpreted at runtime</a:t>
+              <a:t>Meta-data driven declarative parameter specification interpreted at runtime</a:t>
             </a:r>
           </a:p>
           <a:p>
@@ -6941,7 +6920,7 @@
           <a:p>
             <a:r>
               <a:rPr lang="en-US" sz="4000" dirty="0"/>
-              <a:t>Streaming and Cardinality (Rating 3/5)</a:t>
+              <a:t>Streaming and Collections (Rating 3/5)</a:t>
             </a:r>
           </a:p>
         </p:txBody>
@@ -6970,7 +6949,7 @@
         </p:spPr>
         <p:txBody>
           <a:bodyPr>
-            <a:normAutofit fontScale="70000" lnSpcReduction="20000"/>
+            <a:normAutofit fontScale="62500" lnSpcReduction="20000"/>
           </a:bodyPr>
           <a:lstStyle/>
           <a:p>
@@ -6984,19 +6963,10 @@
             </a:r>
             <a:r>
               <a:rPr lang="en-US" dirty="0"/>
-              <a:t> everything which means it flattens collections of collections by one level. (i.e. it’s essentially </a:t>
-            </a:r>
-            <a:r>
-              <a:rPr lang="en-US" i="1" dirty="0" err="1"/>
-              <a:t>flatmap</a:t>
-            </a:r>
-            <a:r>
-              <a:rPr lang="en-US" dirty="0"/>
-              <a:t>)</a:t>
-            </a:r>
-          </a:p>
-          <a:p>
-            <a:pPr lvl="1"/>
+              <a:t> everything which means it flattens collections of collections by one level.</a:t>
+            </a:r>
+          </a:p>
+          <a:p>
             <a:r>
               <a:rPr lang="en-US" dirty="0"/>
               <a:t>This makes the most common scenarios really easy but makes some less common ones impossible.</a:t>
@@ -7032,14 +7002,14 @@
               <a:buNone/>
             </a:pPr>
             <a:r>
-              <a:rPr lang="en-US" sz="2100" dirty="0">
+              <a:rPr lang="en-US" sz="2600" dirty="0">
                 <a:latin typeface="Cascadia Code" panose="020B0609020000020004" pitchFamily="49" charset="0"/>
                 <a:cs typeface="Cascadia Code" panose="020B0609020000020004" pitchFamily="49" charset="0"/>
               </a:rPr>
               <a:t>     </a:t>
             </a:r>
             <a:r>
-              <a:rPr lang="en-US" sz="2100" dirty="0">
+              <a:rPr lang="en-US" sz="2600" dirty="0">
                 <a:solidFill>
                   <a:schemeClr val="accent1"/>
                 </a:solidFill>
@@ -7049,7 +7019,7 @@
               <a:t>[Parameter(</a:t>
             </a:r>
             <a:r>
-              <a:rPr lang="en-US" sz="2100" dirty="0" err="1">
+              <a:rPr lang="en-US" sz="2600" dirty="0" err="1">
                 <a:solidFill>
                   <a:schemeClr val="accent1"/>
                 </a:solidFill>
@@ -7059,7 +7029,7 @@
               <a:t>ValueFromPipeline</a:t>
             </a:r>
             <a:r>
-              <a:rPr lang="en-US" sz="2100" dirty="0">
+              <a:rPr lang="en-US" sz="2600" dirty="0">
                 <a:solidFill>
                   <a:schemeClr val="accent1"/>
                 </a:solidFill>
@@ -7074,7 +7044,7 @@
               <a:buNone/>
             </a:pPr>
             <a:r>
-              <a:rPr lang="en-US" sz="2100" dirty="0">
+              <a:rPr lang="en-US" sz="2600" dirty="0">
                 <a:solidFill>
                   <a:schemeClr val="accent1"/>
                 </a:solidFill>
@@ -7084,7 +7054,7 @@
               <a:t>     public </a:t>
             </a:r>
             <a:r>
-              <a:rPr lang="en-US" sz="2100" dirty="0" err="1">
+              <a:rPr lang="en-US" sz="2600" dirty="0" err="1">
                 <a:solidFill>
                   <a:schemeClr val="accent1"/>
                 </a:solidFill>
@@ -7094,7 +7064,7 @@
               <a:t>PSObject</a:t>
             </a:r>
             <a:r>
-              <a:rPr lang="en-US" sz="2100" dirty="0">
+              <a:rPr lang="en-US" sz="2600" dirty="0">
                 <a:solidFill>
                   <a:schemeClr val="accent1"/>
                 </a:solidFill>
@@ -7104,7 +7074,7 @@
               <a:t> </a:t>
             </a:r>
             <a:r>
-              <a:rPr lang="en-US" sz="2100" dirty="0" err="1">
+              <a:rPr lang="en-US" sz="2600" dirty="0" err="1">
                 <a:solidFill>
                   <a:schemeClr val="accent1"/>
                 </a:solidFill>
@@ -7114,7 +7084,7 @@
               <a:t>InputObject</a:t>
             </a:r>
             <a:r>
-              <a:rPr lang="en-US" sz="2100" dirty="0">
+              <a:rPr lang="en-US" sz="2600" dirty="0">
                 <a:solidFill>
                   <a:schemeClr val="accent1"/>
                 </a:solidFill>
@@ -7124,7 +7094,7 @@
               <a:t> { get; set; } = </a:t>
             </a:r>
             <a:r>
-              <a:rPr lang="en-US" sz="2100" dirty="0" err="1">
+              <a:rPr lang="en-US" sz="2600" dirty="0" err="1">
                 <a:solidFill>
                   <a:schemeClr val="accent1"/>
                 </a:solidFill>
@@ -7134,7 +7104,7 @@
               <a:t>AutomationNull.Value</a:t>
             </a:r>
             <a:r>
-              <a:rPr lang="en-US" sz="2100" dirty="0">
+              <a:rPr lang="en-US" sz="2600" dirty="0">
                 <a:solidFill>
                   <a:schemeClr val="accent1"/>
                 </a:solidFill>
@@ -7167,7 +7137,7 @@
               <a:rPr lang="en-US" dirty="0">
                 <a:cs typeface="Cascadia Code" panose="020B0609020000020004" pitchFamily="49" charset="0"/>
               </a:rPr>
-              <a:t>Too much copying of contents</a:t>
+              <a:t>Too much copying of contents (+= !!!)</a:t>
             </a:r>
           </a:p>
           <a:p>
@@ -8317,7 +8287,7 @@
           <a:p>
             <a:r>
               <a:rPr lang="en-US" dirty="0"/>
-              <a:t>Other Stuff</a:t>
+              <a:t>More Stuff</a:t>
             </a:r>
           </a:p>
         </p:txBody>
@@ -8346,7 +8316,7 @@
         </p:spPr>
         <p:txBody>
           <a:bodyPr>
-            <a:normAutofit fontScale="85000" lnSpcReduction="10000"/>
+            <a:normAutofit fontScale="85000" lnSpcReduction="20000"/>
           </a:bodyPr>
           <a:lstStyle/>
           <a:p>
@@ -8371,7 +8341,7 @@
           <a:p>
             <a:r>
               <a:rPr lang="en-US" dirty="0"/>
-              <a:t>Classes</a:t>
+              <a:t>Early-bound Classes</a:t>
             </a:r>
           </a:p>
           <a:p>
@@ -8382,13 +8352,6 @@
             </a:r>
           </a:p>
           <a:p>
-            <a:pPr lvl="1"/>
-            <a:r>
-              <a:rPr lang="en-US" dirty="0"/>
-              <a:t>Early bound</a:t>
-            </a:r>
-          </a:p>
-          <a:p>
             <a:r>
               <a:rPr lang="en-US" dirty="0"/>
               <a:t>Result of *every* statement goes to output</a:t>
@@ -8434,6 +8397,12 @@
             <a:r>
               <a:rPr lang="en-US" dirty="0"/>
               <a:t>)</a:t>
+            </a:r>
+          </a:p>
+          <a:p>
+            <a:r>
+              <a:rPr lang="en-US" dirty="0"/>
+              <a:t>Keywords: filter, trap</a:t>
             </a:r>
           </a:p>
         </p:txBody>

</xml_diff>